<commit_message>
feat(sih): embed clean stencil blueprint sketch workflow diagram on Slide 3 in PPTX and in-app deck viewer
</commit_message>
<xml_diff>
--- a/SIH2026_Digital_Twin_VARUNA_AI.pptx
+++ b/SIH2026_Digital_Twin_VARUNA_AI.pptx
@@ -2389,7 +2389,7 @@
                 <a:ea typeface="Arial Black" pitchFamily="34" charset="-122"/>
                 <a:cs typeface="Arial Black" pitchFamily="34" charset="-120"/>
               </a:rPr>
-              <a:t>TECHNICAL APPROACH</a:t>
+              <a:t>TECHNICAL APPROACH: SYSTEM WORKFLOW &amp; ARCHITECTURE</a:t>
             </a:r>
             <a:endParaRPr lang="en-US" sz="2400" dirty="0"/>
           </a:p>
@@ -2473,396 +2473,9 @@
           </a:p>
         </p:txBody>
       </p:sp>
-      <p:sp>
-        <p:nvSpPr>
-          <p:cNvPr id="6" name="Text 4"/>
-          <p:cNvSpPr/>
-          <p:nvPr/>
-        </p:nvSpPr>
-        <p:spPr>
-          <a:xfrm>
-            <a:off x="548640" y="1280160"/>
-            <a:ext cx="5669280" cy="320040"/>
-          </a:xfrm>
-          <a:prstGeom prst="rect">
-            <a:avLst/>
-          </a:prstGeom>
-          <a:noFill/>
-          <a:ln/>
-        </p:spPr>
-        <p:txBody>
-          <a:bodyPr wrap="square" rtlCol="0" anchor="ctr"/>
-          <a:lstStyle/>
-          <a:p>
-            <a:pPr indent="0" marL="0">
-              <a:buNone/>
-            </a:pPr>
-            <a:r>
-              <a:rPr lang="en-US" sz="1300" b="1" dirty="0">
-                <a:solidFill>
-                  <a:srgbClr val="0F172A"/>
-                </a:solidFill>
-                <a:latin typeface="Arial" pitchFamily="34" charset="0"/>
-                <a:ea typeface="Arial" pitchFamily="34" charset="-122"/>
-                <a:cs typeface="Arial" pitchFamily="34" charset="-120"/>
-              </a:rPr>
-              <a:t>Technologies to be used:</a:t>
-            </a:r>
-            <a:endParaRPr lang="en-US" sz="1300" dirty="0"/>
-          </a:p>
-        </p:txBody>
-      </p:sp>
-      <p:sp>
-        <p:nvSpPr>
-          <p:cNvPr id="7" name="Text 5"/>
-          <p:cNvSpPr/>
-          <p:nvPr/>
-        </p:nvSpPr>
-        <p:spPr>
-          <a:xfrm>
-            <a:off x="548640" y="1645920"/>
-            <a:ext cx="5669280" cy="2103120"/>
-          </a:xfrm>
-          <a:prstGeom prst="rect">
-            <a:avLst/>
-          </a:prstGeom>
-          <a:noFill/>
-          <a:ln/>
-        </p:spPr>
-        <p:txBody>
-          <a:bodyPr wrap="square" rtlCol="0" anchor="ctr"/>
-          <a:lstStyle/>
-          <a:p>
-            <a:pPr indent="0" marL="0">
-              <a:buNone/>
-            </a:pPr>
-            <a:r>
-              <a:rPr lang="en-US" sz="1100" b="1" dirty="0">
-                <a:solidFill>
-                  <a:srgbClr val="0F172A"/>
-                </a:solidFill>
-                <a:latin typeface="Calibri" pitchFamily="34" charset="0"/>
-                <a:ea typeface="Calibri" pitchFamily="34" charset="-122"/>
-                <a:cs typeface="Calibri" pitchFamily="34" charset="-120"/>
-              </a:rPr>
-              <a:t>• Edge &amp; SCADA Hardware: </a:t>
-            </a:r>
-            <a:pPr indent="0" marL="0">
-              <a:buNone/>
-            </a:pPr>
-            <a:r>
-              <a:rPr lang="en-US" sz="1100" dirty="0">
-                <a:solidFill>
-                  <a:srgbClr val="334155"/>
-                </a:solidFill>
-                <a:latin typeface="Calibri" pitchFamily="34" charset="0"/>
-                <a:ea typeface="Calibri" pitchFamily="34" charset="-122"/>
-                <a:cs typeface="Calibri" pitchFamily="34" charset="-120"/>
-              </a:rPr>
-              <a:t>Wellhead PLCs, MPFM Coriolis meters, PDC torque load cells, Serial USB / Modbus.
-</a:t>
-            </a:r>
-            <a:pPr indent="0" marL="0">
-              <a:buNone/>
-            </a:pPr>
-            <a:r>
-              <a:rPr lang="en-US" sz="1100" b="1" dirty="0">
-                <a:solidFill>
-                  <a:srgbClr val="0F172A"/>
-                </a:solidFill>
-                <a:latin typeface="Calibri" pitchFamily="34" charset="0"/>
-                <a:ea typeface="Calibri" pitchFamily="34" charset="-122"/>
-                <a:cs typeface="Calibri" pitchFamily="34" charset="-120"/>
-              </a:rPr>
-              <a:t>• Physics Engines: </a:t>
-            </a:r>
-            <a:pPr indent="0" marL="0">
-              <a:buNone/>
-            </a:pPr>
-            <a:r>
-              <a:rPr lang="en-US" sz="1100" dirty="0">
-                <a:solidFill>
-                  <a:srgbClr val="334155"/>
-                </a:solidFill>
-                <a:latin typeface="Calibri" pitchFamily="34" charset="0"/>
-                <a:ea typeface="Calibri" pitchFamily="34" charset="-122"/>
-                <a:cs typeface="Calibri" pitchFamily="34" charset="-120"/>
-              </a:rPr>
-              <a:t>ASTM D1250 / API MPMS 11.1, Darcy-Weisbach flow hydraulics, Coriolis resonant density.
-</a:t>
-            </a:r>
-            <a:pPr indent="0" marL="0">
-              <a:buNone/>
-            </a:pPr>
-            <a:r>
-              <a:rPr lang="en-US" sz="1100" b="1" dirty="0">
-                <a:solidFill>
-                  <a:srgbClr val="0F172A"/>
-                </a:solidFill>
-                <a:latin typeface="Calibri" pitchFamily="34" charset="0"/>
-                <a:ea typeface="Calibri" pitchFamily="34" charset="-122"/>
-                <a:cs typeface="Calibri" pitchFamily="34" charset="-120"/>
-              </a:rPr>
-              <a:t>• AI &amp; Signal Processing: </a:t>
-            </a:r>
-            <a:pPr indent="0" marL="0">
-              <a:buNone/>
-            </a:pPr>
-            <a:r>
-              <a:rPr lang="en-US" sz="1100" dirty="0">
-                <a:solidFill>
-                  <a:srgbClr val="334155"/>
-                </a:solidFill>
-                <a:latin typeface="Calibri" pitchFamily="34" charset="0"/>
-                <a:ea typeface="Calibri" pitchFamily="34" charset="-122"/>
-                <a:cs typeface="Calibri" pitchFamily="34" charset="-120"/>
-              </a:rPr>
-              <a:t>1D Kalman state estimators, XGBoost stick-slip anomaly classifiers.
-</a:t>
-            </a:r>
-            <a:pPr indent="0" marL="0">
-              <a:buNone/>
-            </a:pPr>
-            <a:r>
-              <a:rPr lang="en-US" sz="1100" b="1" dirty="0">
-                <a:solidFill>
-                  <a:srgbClr val="0F172A"/>
-                </a:solidFill>
-                <a:latin typeface="Calibri" pitchFamily="34" charset="0"/>
-                <a:ea typeface="Calibri" pitchFamily="34" charset="-122"/>
-                <a:cs typeface="Calibri" pitchFamily="34" charset="-120"/>
-              </a:rPr>
-              <a:t>• 3D Spatial Interface: </a:t>
-            </a:r>
-            <a:pPr indent="0" marL="0">
-              <a:buNone/>
-            </a:pPr>
-            <a:r>
-              <a:rPr lang="en-US" sz="1100" dirty="0">
-                <a:solidFill>
-                  <a:srgbClr val="334155"/>
-                </a:solidFill>
-                <a:latin typeface="Calibri" pitchFamily="34" charset="0"/>
-                <a:ea typeface="Calibri" pitchFamily="34" charset="-122"/>
-                <a:cs typeface="Calibri" pitchFamily="34" charset="-120"/>
-              </a:rPr>
-              <a:t>React Three Fiber / Three.js WebGL with real-time gesture &amp; voice HUD.
-</a:t>
-            </a:r>
-            <a:pPr indent="0" marL="0">
-              <a:buNone/>
-            </a:pPr>
-            <a:r>
-              <a:rPr lang="en-US" sz="1100" b="1" dirty="0">
-                <a:solidFill>
-                  <a:srgbClr val="0F172A"/>
-                </a:solidFill>
-                <a:latin typeface="Calibri" pitchFamily="34" charset="0"/>
-                <a:ea typeface="Calibri" pitchFamily="34" charset="-122"/>
-                <a:cs typeface="Calibri" pitchFamily="34" charset="-120"/>
-              </a:rPr>
-              <a:t>• Local Database Engine: </a:t>
-            </a:r>
-            <a:pPr indent="0" marL="0">
-              <a:buNone/>
-            </a:pPr>
-            <a:r>
-              <a:rPr lang="en-US" sz="1100" dirty="0">
-                <a:solidFill>
-                  <a:srgbClr val="334155"/>
-                </a:solidFill>
-                <a:latin typeface="Calibri" pitchFamily="34" charset="0"/>
-                <a:ea typeface="Calibri" pitchFamily="34" charset="-122"/>
-                <a:cs typeface="Calibri" pitchFamily="34" charset="-120"/>
-              </a:rPr>
-              <a:t>IndexedDB &amp; time-series binary search ledger (&lt;0.1ms query latency).</a:t>
-            </a:r>
-            <a:endParaRPr lang="en-US" sz="1100" dirty="0"/>
-          </a:p>
-        </p:txBody>
-      </p:sp>
-      <p:sp>
-        <p:nvSpPr>
-          <p:cNvPr id="8" name="Text 6"/>
-          <p:cNvSpPr/>
-          <p:nvPr/>
-        </p:nvSpPr>
-        <p:spPr>
-          <a:xfrm>
-            <a:off x="548640" y="3886200"/>
-            <a:ext cx="5669280" cy="320040"/>
-          </a:xfrm>
-          <a:prstGeom prst="rect">
-            <a:avLst/>
-          </a:prstGeom>
-          <a:noFill/>
-          <a:ln/>
-        </p:spPr>
-        <p:txBody>
-          <a:bodyPr wrap="square" rtlCol="0" anchor="ctr"/>
-          <a:lstStyle/>
-          <a:p>
-            <a:pPr indent="0" marL="0">
-              <a:buNone/>
-            </a:pPr>
-            <a:r>
-              <a:rPr lang="en-US" sz="1300" b="1" dirty="0">
-                <a:solidFill>
-                  <a:srgbClr val="0F172A"/>
-                </a:solidFill>
-                <a:latin typeface="Arial" pitchFamily="34" charset="0"/>
-                <a:ea typeface="Arial" pitchFamily="34" charset="-122"/>
-                <a:cs typeface="Arial" pitchFamily="34" charset="-120"/>
-              </a:rPr>
-              <a:t>Methodology and process for implementation:</a:t>
-            </a:r>
-            <a:endParaRPr lang="en-US" sz="1300" dirty="0"/>
-          </a:p>
-        </p:txBody>
-      </p:sp>
-      <p:sp>
-        <p:nvSpPr>
-          <p:cNvPr id="9" name="Text 7"/>
-          <p:cNvSpPr/>
-          <p:nvPr/>
-        </p:nvSpPr>
-        <p:spPr>
-          <a:xfrm>
-            <a:off x="548640" y="4251960"/>
-            <a:ext cx="5669280" cy="1920240"/>
-          </a:xfrm>
-          <a:prstGeom prst="rect">
-            <a:avLst/>
-          </a:prstGeom>
-          <a:noFill/>
-          <a:ln/>
-        </p:spPr>
-        <p:txBody>
-          <a:bodyPr wrap="square" rtlCol="0" anchor="ctr"/>
-          <a:lstStyle/>
-          <a:p>
-            <a:pPr indent="0" marL="0">
-              <a:buNone/>
-            </a:pPr>
-            <a:r>
-              <a:rPr lang="en-US" sz="1050" b="1" dirty="0">
-                <a:solidFill>
-                  <a:srgbClr val="0F172A"/>
-                </a:solidFill>
-                <a:latin typeface="Calibri" pitchFamily="34" charset="0"/>
-                <a:ea typeface="Calibri" pitchFamily="34" charset="-122"/>
-                <a:cs typeface="Calibri" pitchFamily="34" charset="-120"/>
-              </a:rPr>
-              <a:t>1. Multi-Rate Ingestion: </a:t>
-            </a:r>
-            <a:pPr indent="0" marL="0">
-              <a:buNone/>
-            </a:pPr>
-            <a:r>
-              <a:rPr lang="en-US" sz="1050" dirty="0">
-                <a:solidFill>
-                  <a:srgbClr val="334155"/>
-                </a:solidFill>
-                <a:latin typeface="Calibri" pitchFamily="34" charset="0"/>
-                <a:ea typeface="Calibri" pitchFamily="34" charset="-122"/>
-                <a:cs typeface="Calibri" pitchFamily="34" charset="-120"/>
-              </a:rPr>
-              <a:t>50.0 Hz subsea telemetry stream fed into edge Kalman filters.
-</a:t>
-            </a:r>
-            <a:pPr indent="0" marL="0">
-              <a:buNone/>
-            </a:pPr>
-            <a:r>
-              <a:rPr lang="en-US" sz="1050" b="1" dirty="0">
-                <a:solidFill>
-                  <a:srgbClr val="0F172A"/>
-                </a:solidFill>
-                <a:latin typeface="Calibri" pitchFamily="34" charset="0"/>
-                <a:ea typeface="Calibri" pitchFamily="34" charset="-122"/>
-                <a:cs typeface="Calibri" pitchFamily="34" charset="-120"/>
-              </a:rPr>
-              <a:t>2. Physics Deconvolution: </a:t>
-            </a:r>
-            <a:pPr indent="0" marL="0">
-              <a:buNone/>
-            </a:pPr>
-            <a:r>
-              <a:rPr lang="en-US" sz="1050" dirty="0">
-                <a:solidFill>
-                  <a:srgbClr val="334155"/>
-                </a:solidFill>
-                <a:latin typeface="Calibri" pitchFamily="34" charset="0"/>
-                <a:ea typeface="Calibri" pitchFamily="34" charset="-122"/>
-                <a:cs typeface="Calibri" pitchFamily="34" charset="-120"/>
-              </a:rPr>
-              <a:t>Equations solve multiphase cut and ASTM temperature/pressure corrections.
-</a:t>
-            </a:r>
-            <a:pPr indent="0" marL="0">
-              <a:buNone/>
-            </a:pPr>
-            <a:r>
-              <a:rPr lang="en-US" sz="1050" b="1" dirty="0">
-                <a:solidFill>
-                  <a:srgbClr val="0F172A"/>
-                </a:solidFill>
-                <a:latin typeface="Calibri" pitchFamily="34" charset="0"/>
-                <a:ea typeface="Calibri" pitchFamily="34" charset="-122"/>
-                <a:cs typeface="Calibri" pitchFamily="34" charset="-120"/>
-              </a:rPr>
-              <a:t>3. 3D Spatial Synchronization: </a:t>
-            </a:r>
-            <a:pPr indent="0" marL="0">
-              <a:buNone/>
-            </a:pPr>
-            <a:r>
-              <a:rPr lang="en-US" sz="1050" dirty="0">
-                <a:solidFill>
-                  <a:srgbClr val="334155"/>
-                </a:solidFill>
-                <a:latin typeface="Calibri" pitchFamily="34" charset="0"/>
-                <a:ea typeface="Calibri" pitchFamily="34" charset="-122"/>
-                <a:cs typeface="Calibri" pitchFamily="34" charset="-120"/>
-              </a:rPr>
-              <a:t>WebGL digital twin renders animated flows, riser stresses, and PDC rotation.
-</a:t>
-            </a:r>
-            <a:pPr indent="0" marL="0">
-              <a:buNone/>
-            </a:pPr>
-            <a:r>
-              <a:rPr lang="en-US" sz="1050" b="1" dirty="0">
-                <a:solidFill>
-                  <a:srgbClr val="0F172A"/>
-                </a:solidFill>
-                <a:latin typeface="Calibri" pitchFamily="34" charset="0"/>
-                <a:ea typeface="Calibri" pitchFamily="34" charset="-122"/>
-                <a:cs typeface="Calibri" pitchFamily="34" charset="-120"/>
-              </a:rPr>
-              <a:t>4. Midnight EOD Settlement: </a:t>
-            </a:r>
-            <a:pPr indent="0" marL="0">
-              <a:buNone/>
-            </a:pPr>
-            <a:r>
-              <a:rPr lang="en-US" sz="1050" dirty="0">
-                <a:solidFill>
-                  <a:srgbClr val="334155"/>
-                </a:solidFill>
-                <a:latin typeface="Calibri" pitchFamily="34" charset="0"/>
-                <a:ea typeface="Calibri" pitchFamily="34" charset="-122"/>
-                <a:cs typeface="Calibri" pitchFamily="34" charset="-120"/>
-              </a:rPr>
-              <a:t>Automated 12:00 AM daemon seals certified daily DGH compliance ledgers.</a:t>
-            </a:r>
-            <a:endParaRPr lang="en-US" sz="1050" dirty="0"/>
-          </a:p>
-        </p:txBody>
-      </p:sp>
       <p:pic>
         <p:nvPicPr>
-          <p:cNvPr id="10" name="Image 0" descr="E:\Digital Twin\public\presentation\rig_diorama_colored_1789147250513.jpg">    </p:cNvPr>
+          <p:cNvPr id="6" name="Image 0" descr="E:\Digital Twin\public\presentation\workflow_diagram_stencil.jpg">    </p:cNvPr>
           <p:cNvPicPr>
             <a:picLocks noChangeAspect="1"/>
           </p:cNvPicPr>
@@ -2876,17 +2489,223 @@
         </p:blipFill>
         <p:spPr>
           <a:xfrm>
-            <a:off x="6492240" y="1280160"/>
-            <a:ext cx="5120640" cy="2377440"/>
+            <a:off x="548640" y="1188720"/>
+            <a:ext cx="11091672" cy="3246120"/>
           </a:xfrm>
           <a:prstGeom prst="rect">
             <a:avLst/>
           </a:prstGeom>
         </p:spPr>
       </p:pic>
+      <p:sp>
+        <p:nvSpPr>
+          <p:cNvPr id="7" name="Shape 4"/>
+          <p:cNvSpPr/>
+          <p:nvPr/>
+        </p:nvSpPr>
+        <p:spPr>
+          <a:xfrm>
+            <a:off x="548640" y="4526280"/>
+            <a:ext cx="7498080" cy="1691640"/>
+          </a:xfrm>
+          <a:prstGeom prst="roundRect">
+            <a:avLst>
+              <a:gd name="adj" fmla="val 4324"/>
+            </a:avLst>
+          </a:prstGeom>
+          <a:solidFill>
+            <a:srgbClr val="F8FAFC"/>
+          </a:solidFill>
+          <a:ln w="12700">
+            <a:solidFill>
+              <a:srgbClr val="CBD5E1"/>
+            </a:solidFill>
+            <a:prstDash val="solid"/>
+          </a:ln>
+        </p:spPr>
+      </p:sp>
+      <p:sp>
+        <p:nvSpPr>
+          <p:cNvPr id="8" name="Text 5"/>
+          <p:cNvSpPr/>
+          <p:nvPr/>
+        </p:nvSpPr>
+        <p:spPr>
+          <a:xfrm>
+            <a:off x="731520" y="4599432"/>
+            <a:ext cx="7132320" cy="228600"/>
+          </a:xfrm>
+          <a:prstGeom prst="rect">
+            <a:avLst/>
+          </a:prstGeom>
+          <a:noFill/>
+          <a:ln/>
+        </p:spPr>
+        <p:txBody>
+          <a:bodyPr wrap="square" rtlCol="0" anchor="ctr"/>
+          <a:lstStyle/>
+          <a:p>
+            <a:pPr indent="0" marL="0">
+              <a:buNone/>
+            </a:pPr>
+            <a:r>
+              <a:rPr lang="en-US" sz="1000" b="1" dirty="0">
+                <a:solidFill>
+                  <a:srgbClr val="1E3A8A"/>
+                </a:solidFill>
+                <a:latin typeface="Arial" pitchFamily="34" charset="0"/>
+                <a:ea typeface="Arial" pitchFamily="34" charset="-122"/>
+                <a:cs typeface="Arial" pitchFamily="34" charset="-120"/>
+              </a:rPr>
+              <a:t>CORE TECHNOLOGY STACK &amp; COMMUNICATION PROTOCOLS</a:t>
+            </a:r>
+            <a:endParaRPr lang="en-US" sz="1000" dirty="0"/>
+          </a:p>
+        </p:txBody>
+      </p:sp>
+      <p:sp>
+        <p:nvSpPr>
+          <p:cNvPr id="9" name="Text 6"/>
+          <p:cNvSpPr/>
+          <p:nvPr/>
+        </p:nvSpPr>
+        <p:spPr>
+          <a:xfrm>
+            <a:off x="731520" y="4818888"/>
+            <a:ext cx="7132320" cy="1325880"/>
+          </a:xfrm>
+          <a:prstGeom prst="rect">
+            <a:avLst/>
+          </a:prstGeom>
+          <a:noFill/>
+          <a:ln/>
+        </p:spPr>
+        <p:txBody>
+          <a:bodyPr wrap="square" rtlCol="0" anchor="ctr"/>
+          <a:lstStyle/>
+          <a:p>
+            <a:pPr indent="0" marL="0">
+              <a:buNone/>
+            </a:pPr>
+            <a:r>
+              <a:rPr lang="en-US" sz="850" b="1" dirty="0">
+                <a:solidFill>
+                  <a:srgbClr val="0F172A"/>
+                </a:solidFill>
+                <a:latin typeface="Calibri" pitchFamily="34" charset="0"/>
+                <a:ea typeface="Calibri" pitchFamily="34" charset="-122"/>
+                <a:cs typeface="Calibri" pitchFamily="34" charset="-120"/>
+              </a:rPr>
+              <a:t>• Stage 1 (Edge SCADA): </a:t>
+            </a:r>
+            <a:pPr indent="0" marL="0">
+              <a:buNone/>
+            </a:pPr>
+            <a:r>
+              <a:rPr lang="en-US" sz="850" dirty="0">
+                <a:solidFill>
+                  <a:srgbClr val="334155"/>
+                </a:solidFill>
+                <a:latin typeface="Calibri" pitchFamily="34" charset="0"/>
+                <a:ea typeface="Calibri" pitchFamily="34" charset="-122"/>
+                <a:cs typeface="Calibri" pitchFamily="34" charset="-120"/>
+              </a:rPr>
+              <a:t>Modbus RTU/TCP, OPC-UA, WITSML, Serial USB WebGateway (50Hz / 20ms).
+</a:t>
+            </a:r>
+            <a:pPr indent="0" marL="0">
+              <a:buNone/>
+            </a:pPr>
+            <a:r>
+              <a:rPr lang="en-US" sz="850" b="1" dirty="0">
+                <a:solidFill>
+                  <a:srgbClr val="0F172A"/>
+                </a:solidFill>
+                <a:latin typeface="Calibri" pitchFamily="34" charset="0"/>
+                <a:ea typeface="Calibri" pitchFamily="34" charset="-122"/>
+                <a:cs typeface="Calibri" pitchFamily="34" charset="-120"/>
+              </a:rPr>
+              <a:t>• Stage 2 (Denoising): </a:t>
+            </a:r>
+            <a:pPr indent="0" marL="0">
+              <a:buNone/>
+            </a:pPr>
+            <a:r>
+              <a:rPr lang="en-US" sz="850" dirty="0">
+                <a:solidFill>
+                  <a:srgbClr val="334155"/>
+                </a:solidFill>
+                <a:latin typeface="Calibri" pitchFamily="34" charset="0"/>
+                <a:ea typeface="Calibri" pitchFamily="34" charset="-122"/>
+                <a:cs typeface="Calibri" pitchFamily="34" charset="-120"/>
+              </a:rPr>
+              <a:t>Discrete 1D Kalman recursive state estimator + 180-day local buffer ledger (&lt;0.1ms query).
+</a:t>
+            </a:r>
+            <a:pPr indent="0" marL="0">
+              <a:buNone/>
+            </a:pPr>
+            <a:r>
+              <a:rPr lang="en-US" sz="850" b="1" dirty="0">
+                <a:solidFill>
+                  <a:srgbClr val="0F172A"/>
+                </a:solidFill>
+                <a:latin typeface="Calibri" pitchFamily="34" charset="0"/>
+                <a:ea typeface="Calibri" pitchFamily="34" charset="-122"/>
+                <a:cs typeface="Calibri" pitchFamily="34" charset="-120"/>
+              </a:rPr>
+              <a:t>• Stage 3 (Physics &amp; AI): </a:t>
+            </a:r>
+            <a:pPr indent="0" marL="0">
+              <a:buNone/>
+            </a:pPr>
+            <a:r>
+              <a:rPr lang="en-US" sz="850" dirty="0">
+                <a:solidFill>
+                  <a:srgbClr val="334155"/>
+                </a:solidFill>
+                <a:latin typeface="Calibri" pitchFamily="34" charset="0"/>
+                <a:ea typeface="Calibri" pitchFamily="34" charset="-122"/>
+                <a:cs typeface="Calibri" pitchFamily="34" charset="-120"/>
+              </a:rPr>
+              <a:t>Darcy-Weisbach multiphase hydraulics, ASTM D1250 / API MPMS 11.1 net oil solver, XGBoost AI.
+</a:t>
+            </a:r>
+            <a:pPr indent="0" marL="0">
+              <a:buNone/>
+            </a:pPr>
+            <a:r>
+              <a:rPr lang="en-US" sz="850" b="1" dirty="0">
+                <a:solidFill>
+                  <a:srgbClr val="0F172A"/>
+                </a:solidFill>
+                <a:latin typeface="Calibri" pitchFamily="34" charset="0"/>
+                <a:ea typeface="Calibri" pitchFamily="34" charset="-122"/>
+                <a:cs typeface="Calibri" pitchFamily="34" charset="-120"/>
+              </a:rPr>
+              <a:t>• Stage 4 &amp; 5 (Twin &amp; Audit): </a:t>
+            </a:r>
+            <a:pPr indent="0" marL="0">
+              <a:buNone/>
+            </a:pPr>
+            <a:r>
+              <a:rPr lang="en-US" sz="850" dirty="0">
+                <a:solidFill>
+                  <a:srgbClr val="334155"/>
+                </a:solidFill>
+                <a:latin typeface="Calibri" pitchFamily="34" charset="0"/>
+                <a:ea typeface="Calibri" pitchFamily="34" charset="-122"/>
+                <a:cs typeface="Calibri" pitchFamily="34" charset="-120"/>
+              </a:rPr>
+              <a:t>Three.js WebGL 3D spatial twin with gestures/voice + automated 12:00 Midnight DGH audit ledger.</a:t>
+            </a:r>
+            <a:endParaRPr lang="en-US" sz="850" dirty="0"/>
+          </a:p>
+        </p:txBody>
+      </p:sp>
       <p:pic>
         <p:nvPicPr>
-          <p:cNvPr id="11" name="Image 1" descr="E:\Digital Twin\public\presentation\hologram_digital_twin_1789148609789.jpg">    </p:cNvPr>
+          <p:cNvPr id="10" name="Image 1" descr="E:\Digital Twin\public\presentation\rig_diorama_colored_1789147250513.jpg">    </p:cNvPr>
           <p:cNvPicPr>
             <a:picLocks noChangeAspect="1"/>
           </p:cNvPicPr>
@@ -2900,8 +2719,32 @@
         </p:blipFill>
         <p:spPr>
           <a:xfrm>
-            <a:off x="6492240" y="3794760"/>
-            <a:ext cx="5120640" cy="2377440"/>
+            <a:off x="8229600" y="4526280"/>
+            <a:ext cx="1645920" cy="1691640"/>
+          </a:xfrm>
+          <a:prstGeom prst="rect">
+            <a:avLst/>
+          </a:prstGeom>
+        </p:spPr>
+      </p:pic>
+      <p:pic>
+        <p:nvPicPr>
+          <p:cNvPr id="11" name="Image 2" descr="E:\Digital Twin\public\presentation\hologram_digital_twin_1789148609789.jpg">    </p:cNvPr>
+          <p:cNvPicPr>
+            <a:picLocks noChangeAspect="1"/>
+          </p:cNvPicPr>
+          <p:nvPr/>
+        </p:nvPicPr>
+        <p:blipFill>
+          <a:blip r:embed="rId3"/>
+          <a:stretch>
+            <a:fillRect/>
+          </a:stretch>
+        </p:blipFill>
+        <p:spPr>
+          <a:xfrm>
+            <a:off x="9994392" y="4526280"/>
+            <a:ext cx="1645920" cy="1691640"/>
           </a:xfrm>
           <a:prstGeom prst="rect">
             <a:avLst/>

</xml_diff>

<commit_message>
feat(voice): implement Varuna-AI wake word architecture, 28 voice commands, glowing gesture HUD docking, and 1-minute smooth ocean tides
</commit_message>
<xml_diff>
--- a/SIH2026_Digital_Twin_VARUNA_AI.pptx
+++ b/SIH2026_Digital_Twin_VARUNA_AI.pptx
@@ -4,17 +4,17 @@
   <p:sldMasterIdLst>
     <p:sldMasterId id="2147483648" r:id="rId1"/>
   </p:sldMasterIdLst>
+  <p:notesMasterIdLst>
+    <p:notesMasterId r:id="rId8"/>
+  </p:notesMasterIdLst>
   <p:sldIdLst>
-    <p:sldId id="256" r:id="rId2"/>
+    <p:sldId id="291" r:id="rId2"/>
     <p:sldId id="257" r:id="rId3"/>
     <p:sldId id="258" r:id="rId4"/>
     <p:sldId id="259" r:id="rId5"/>
     <p:sldId id="260" r:id="rId6"/>
     <p:sldId id="261" r:id="rId7"/>
   </p:sldIdLst>
-  <p:notesMasterIdLst>
-    <p:notesMasterId r:id="rId8"/>
-  </p:notesMasterIdLst>
   <p:sldSz cx="12192000" cy="6858000"/>
   <p:notesSz cx="6858000" cy="12192000"/>
   <p:defaultTextStyle>
@@ -109,6 +109,11 @@
       </a:defRPr>
     </a:lvl9pPr>
   </p:defaultTextStyle>
+  <p:extLst>
+    <p:ext uri="{EFAFB233-063F-42B5-8137-9DF3F51BA10A}">
+      <p15:sldGuideLst xmlns:p15="http://schemas.microsoft.com/office/powerpoint/2012/main"/>
+    </p:ext>
+  </p:extLst>
 </p:presentation>
 </file>
 
@@ -134,234 +139,10 @@
           <a:chExt cx="0" cy="0"/>
         </a:xfrm>
       </p:grpSpPr>
-      <p:sp>
-        <p:nvSpPr>
-          <p:cNvPr id="2" name="Header Placeholder 1"/>
-          <p:cNvSpPr>
-            <a:spLocks noGrp="1"/>
-          </p:cNvSpPr>
-          <p:nvPr>
-            <p:ph type="hdr" sz="quarter"/>
-          </p:nvPr>
-        </p:nvSpPr>
-        <p:spPr>
-          <a:xfrm>
-            <a:off x="0" y="0"/>
-            <a:ext cx="2971800" cy="458788"/>
-          </a:xfrm>
-          <a:prstGeom prst="rect">
-            <a:avLst/>
-          </a:prstGeom>
-        </p:spPr>
-        <p:txBody>
-          <a:bodyPr vert="horz" lIns="91440" tIns="45720" rIns="91440" bIns="45720" rtlCol="0"/>
-          <a:lstStyle>
-            <a:lvl1pPr algn="l">
-              <a:defRPr sz="1200"/>
-            </a:lvl1pPr>
-          </a:lstStyle>
-          <a:p>
-            <a:endParaRPr lang="en-US"/>
-          </a:p>
-        </p:txBody>
-      </p:sp>
-      <p:sp>
-        <p:nvSpPr>
-          <p:cNvPr id="3" name="Date Placeholder 2"/>
-          <p:cNvSpPr>
-            <a:spLocks noGrp="1"/>
-          </p:cNvSpPr>
-          <p:nvPr>
-            <p:ph type="dt" idx="1"/>
-          </p:nvPr>
-        </p:nvSpPr>
-        <p:spPr>
-          <a:xfrm>
-            <a:off x="3884613" y="0"/>
-            <a:ext cx="2971800" cy="458788"/>
-          </a:xfrm>
-          <a:prstGeom prst="rect">
-            <a:avLst/>
-          </a:prstGeom>
-        </p:spPr>
-        <p:txBody>
-          <a:bodyPr vert="horz" lIns="91440" tIns="45720" rIns="91440" bIns="45720" rtlCol="0"/>
-          <a:lstStyle>
-            <a:lvl1pPr algn="r">
-              <a:defRPr sz="1200"/>
-            </a:lvl1pPr>
-          </a:lstStyle>
-          <a:p>
-            <a:fld id="{5282F153-3F37-0F45-9E97-73ACFA13230C}" type="datetimeFigureOut">
-              <a:rPr lang="en-US"/>
-              <a:t>7/23/19</a:t>
-            </a:fld>
-            <a:endParaRPr lang="en-US"/>
-          </a:p>
-        </p:txBody>
-      </p:sp>
-      <p:sp>
-        <p:nvSpPr>
-          <p:cNvPr id="4" name="Slide Image Placeholder 3"/>
-          <p:cNvSpPr>
-            <a:spLocks noGrp="1" noRot="1" noChangeAspect="1"/>
-          </p:cNvSpPr>
-          <p:nvPr>
-            <p:ph type="sldImg" idx="2"/>
-          </p:nvPr>
-        </p:nvSpPr>
-        <p:spPr>
-          <a:xfrm>
-            <a:off x="685800" y="1143000"/>
-            <a:ext cx="5486400" cy="3086100"/>
-          </a:xfrm>
-          <a:prstGeom prst="rect">
-            <a:avLst/>
-          </a:prstGeom>
-          <a:noFill/>
-          <a:ln w="12700">
-            <a:solidFill>
-              <a:prstClr val="black"/>
-            </a:solidFill>
-          </a:ln>
-        </p:spPr>
-        <p:txBody>
-          <a:bodyPr vert="horz" lIns="91440" tIns="45720" rIns="91440" bIns="45720" rtlCol="0" anchor="ctr"/>
-          <a:lstStyle/>
-          <a:p>
-            <a:endParaRPr lang="en-US"/>
-          </a:p>
-        </p:txBody>
-      </p:sp>
-      <p:sp>
-        <p:nvSpPr>
-          <p:cNvPr id="5" name="Notes Placeholder 4"/>
-          <p:cNvSpPr>
-            <a:spLocks noGrp="1"/>
-          </p:cNvSpPr>
-          <p:nvPr>
-            <p:ph type="body" sz="quarter" idx="3"/>
-          </p:nvPr>
-        </p:nvSpPr>
-        <p:spPr>
-          <a:xfrm>
-            <a:off x="685800" y="4400550"/>
-            <a:ext cx="5486400" cy="3600450"/>
-          </a:xfrm>
-          <a:prstGeom prst="rect">
-            <a:avLst/>
-          </a:prstGeom>
-        </p:spPr>
-        <p:txBody>
-          <a:bodyPr vert="horz" lIns="91440" tIns="45720" rIns="91440" bIns="45720" rtlCol="0"/>
-          <a:lstStyle/>
-          <a:p>
-            <a:pPr lvl="0"/>
-            <a:r>
-              <a:rPr lang="en-US"/>
-              <a:t>Click to edit Master text styles</a:t>
-            </a:r>
-          </a:p>
-          <a:p>
-            <a:pPr lvl="1"/>
-            <a:r>
-              <a:rPr lang="en-US"/>
-              <a:t>Second level</a:t>
-            </a:r>
-          </a:p>
-          <a:p>
-            <a:pPr lvl="2"/>
-            <a:r>
-              <a:rPr lang="en-US"/>
-              <a:t>Third level</a:t>
-            </a:r>
-          </a:p>
-          <a:p>
-            <a:pPr lvl="3"/>
-            <a:r>
-              <a:rPr lang="en-US"/>
-              <a:t>Fourth level</a:t>
-            </a:r>
-          </a:p>
-          <a:p>
-            <a:pPr lvl="4"/>
-            <a:r>
-              <a:rPr lang="en-US"/>
-              <a:t>Fifth level</a:t>
-            </a:r>
-          </a:p>
-        </p:txBody>
-      </p:sp>
-      <p:sp>
-        <p:nvSpPr>
-          <p:cNvPr id="6" name="Footer Placeholder 5"/>
-          <p:cNvSpPr>
-            <a:spLocks noGrp="1"/>
-          </p:cNvSpPr>
-          <p:nvPr>
-            <p:ph type="ftr" sz="quarter" idx="4"/>
-          </p:nvPr>
-        </p:nvSpPr>
-        <p:spPr>
-          <a:xfrm>
-            <a:off x="0" y="8685213"/>
-            <a:ext cx="2971800" cy="458787"/>
-          </a:xfrm>
-          <a:prstGeom prst="rect">
-            <a:avLst/>
-          </a:prstGeom>
-        </p:spPr>
-        <p:txBody>
-          <a:bodyPr vert="horz" lIns="91440" tIns="45720" rIns="91440" bIns="45720" rtlCol="0" anchor="b"/>
-          <a:lstStyle>
-            <a:lvl1pPr algn="l">
-              <a:defRPr sz="1200"/>
-            </a:lvl1pPr>
-          </a:lstStyle>
-          <a:p>
-            <a:endParaRPr lang="en-US"/>
-          </a:p>
-        </p:txBody>
-      </p:sp>
-      <p:sp>
-        <p:nvSpPr>
-          <p:cNvPr id="7" name="Slide Number Placeholder 6"/>
-          <p:cNvSpPr>
-            <a:spLocks noGrp="1"/>
-          </p:cNvSpPr>
-          <p:nvPr>
-            <p:ph type="sldNum" sz="quarter" idx="5"/>
-          </p:nvPr>
-        </p:nvSpPr>
-        <p:spPr>
-          <a:xfrm>
-            <a:off x="3884613" y="8685213"/>
-            <a:ext cx="2971800" cy="458787"/>
-          </a:xfrm>
-          <a:prstGeom prst="rect">
-            <a:avLst/>
-          </a:prstGeom>
-        </p:spPr>
-        <p:txBody>
-          <a:bodyPr vert="horz" lIns="91440" tIns="45720" rIns="91440" bIns="45720" rtlCol="0" anchor="b"/>
-          <a:lstStyle>
-            <a:lvl1pPr algn="r">
-              <a:defRPr sz="1200"/>
-            </a:lvl1pPr>
-          </a:lstStyle>
-          <a:p>
-            <a:fld id="{CE5E9CC1-C706-0F49-92D6-E571CC5EEA8F}" type="slidenum">
-              <a:rPr lang="en-US"/>
-              <a:t>‹#›</a:t>
-            </a:fld>
-            <a:endParaRPr lang="en-US"/>
-          </a:p>
-        </p:txBody>
-      </p:sp>
     </p:spTree>
     <p:extLst>
       <p:ext uri="{BB962C8B-B14F-4D97-AF65-F5344CB8AC3E}">
-        <p14:creationId xmlns:p14="http://schemas.microsoft.com/office/powerpoint/2010/main" val="1024086991"/>
+        <p14:creationId xmlns:p14="http://schemas.microsoft.com/office/powerpoint/2010/main" val="1804889057"/>
       </p:ext>
     </p:extLst>
   </p:cSld>
@@ -505,10 +286,6 @@
           <a:bodyPr/>
           <a:lstStyle/>
           <a:p>
-            <a:r>
-              <a:rPr lang="en-US" dirty="0"/>
-              <a:t/>
-            </a:r>
             <a:endParaRPr lang="en-US" dirty="0"/>
           </a:p>
         </p:txBody>
@@ -530,7 +307,7 @@
           <a:p>
             <a:fld id="{F7021451-1387-4CA6-816F-3879F97B5CBC}" type="slidenum">
               <a:rPr lang="en-US"/>
-              <a:t>1</a:t>
+              <a:t>2</a:t>
             </a:fld>
             <a:endParaRPr lang="en-US"/>
           </a:p>
@@ -593,10 +370,6 @@
           <a:bodyPr/>
           <a:lstStyle/>
           <a:p>
-            <a:r>
-              <a:rPr lang="en-US" dirty="0"/>
-              <a:t/>
-            </a:r>
             <a:endParaRPr lang="en-US" dirty="0"/>
           </a:p>
         </p:txBody>
@@ -618,7 +391,7 @@
           <a:p>
             <a:fld id="{F7021451-1387-4CA6-816F-3879F97B5CBC}" type="slidenum">
               <a:rPr lang="en-US"/>
-              <a:t>2</a:t>
+              <a:t>3</a:t>
             </a:fld>
             <a:endParaRPr lang="en-US"/>
           </a:p>
@@ -681,10 +454,6 @@
           <a:bodyPr/>
           <a:lstStyle/>
           <a:p>
-            <a:r>
-              <a:rPr lang="en-US" dirty="0"/>
-              <a:t/>
-            </a:r>
             <a:endParaRPr lang="en-US" dirty="0"/>
           </a:p>
         </p:txBody>
@@ -706,7 +475,7 @@
           <a:p>
             <a:fld id="{F7021451-1387-4CA6-816F-3879F97B5CBC}" type="slidenum">
               <a:rPr lang="en-US"/>
-              <a:t>3</a:t>
+              <a:t>4</a:t>
             </a:fld>
             <a:endParaRPr lang="en-US"/>
           </a:p>
@@ -769,10 +538,6 @@
           <a:bodyPr/>
           <a:lstStyle/>
           <a:p>
-            <a:r>
-              <a:rPr lang="en-US" dirty="0"/>
-              <a:t/>
-            </a:r>
             <a:endParaRPr lang="en-US" dirty="0"/>
           </a:p>
         </p:txBody>
@@ -794,7 +559,7 @@
           <a:p>
             <a:fld id="{F7021451-1387-4CA6-816F-3879F97B5CBC}" type="slidenum">
               <a:rPr lang="en-US"/>
-              <a:t>4</a:t>
+              <a:t>5</a:t>
             </a:fld>
             <a:endParaRPr lang="en-US"/>
           </a:p>
@@ -857,98 +622,6 @@
           <a:bodyPr/>
           <a:lstStyle/>
           <a:p>
-            <a:r>
-              <a:rPr lang="en-US" dirty="0"/>
-              <a:t/>
-            </a:r>
-            <a:endParaRPr lang="en-US" dirty="0"/>
-          </a:p>
-        </p:txBody>
-      </p:sp>
-      <p:sp>
-        <p:nvSpPr>
-          <p:cNvPr id="4" name="Slide Number Placeholder 3"/>
-          <p:cNvSpPr>
-            <a:spLocks noGrp="1"/>
-          </p:cNvSpPr>
-          <p:nvPr>
-            <p:ph type="sldNum" sz="quarter" idx="10"/>
-          </p:nvPr>
-        </p:nvSpPr>
-        <p:spPr/>
-        <p:txBody>
-          <a:bodyPr/>
-          <a:lstStyle/>
-          <a:p>
-            <a:fld id="{F7021451-1387-4CA6-816F-3879F97B5CBC}" type="slidenum">
-              <a:rPr lang="en-US"/>
-              <a:t>5</a:t>
-            </a:fld>
-            <a:endParaRPr lang="en-US"/>
-          </a:p>
-        </p:txBody>
-      </p:sp>
-    </p:spTree>
-    <p:extLst>
-      <p:ext uri="{BB962C8B-B14F-4D97-AF65-F5344CB8AC3E}">
-        <p14:creationId xmlns:p14="http://schemas.microsoft.com/office/powerpoint/2010/main" val="1024086991"/>
-      </p:ext>
-    </p:extLst>
-  </p:cSld>
-  <p:clrMapOvr>
-    <a:masterClrMapping/>
-  </p:clrMapOvr>
-</p:notes>
-</file>
-
-<file path=ppt/notesSlides/notesSlide6.xml><?xml version="1.0" encoding="utf-8"?>
-<p:notes xmlns:a="http://schemas.openxmlformats.org/drawingml/2006/main" xmlns:r="http://schemas.openxmlformats.org/officeDocument/2006/relationships" xmlns:p="http://schemas.openxmlformats.org/presentationml/2006/main">
-  <p:cSld>
-    <p:spTree>
-      <p:nvGrpSpPr>
-        <p:cNvPr id="1" name=""/>
-        <p:cNvGrpSpPr/>
-        <p:nvPr/>
-      </p:nvGrpSpPr>
-      <p:grpSpPr>
-        <a:xfrm>
-          <a:off x="0" y="0"/>
-          <a:ext cx="0" cy="0"/>
-          <a:chOff x="0" y="0"/>
-          <a:chExt cx="0" cy="0"/>
-        </a:xfrm>
-      </p:grpSpPr>
-      <p:sp>
-        <p:nvSpPr>
-          <p:cNvPr id="2" name="Slide Image Placeholder 1"/>
-          <p:cNvSpPr>
-            <a:spLocks noGrp="1" noRot="1" noChangeAspect="1"/>
-          </p:cNvSpPr>
-          <p:nvPr>
-            <p:ph type="sldImg"/>
-          </p:nvPr>
-        </p:nvSpPr>
-        <p:spPr/>
-      </p:sp>
-      <p:sp>
-        <p:nvSpPr>
-          <p:cNvPr id="3" name="Notes Placeholder 2"/>
-          <p:cNvSpPr>
-            <a:spLocks noGrp="1"/>
-          </p:cNvSpPr>
-          <p:nvPr>
-            <p:ph type="body" idx="1"/>
-          </p:nvPr>
-        </p:nvSpPr>
-        <p:spPr/>
-        <p:txBody>
-          <a:bodyPr/>
-          <a:lstStyle/>
-          <a:p>
-            <a:r>
-              <a:rPr lang="en-US" dirty="0"/>
-              <a:t/>
-            </a:r>
             <a:endParaRPr lang="en-US" dirty="0"/>
           </a:p>
         </p:txBody>
@@ -1019,9 +692,273 @@
 </p:sldLayout>
 </file>
 
+<file path=ppt/slideLayouts/slideLayout2.xml><?xml version="1.0" encoding="utf-8"?>
+<p:sldLayout xmlns:a="http://schemas.openxmlformats.org/drawingml/2006/main" xmlns:r="http://schemas.openxmlformats.org/officeDocument/2006/relationships" xmlns:p="http://schemas.openxmlformats.org/presentationml/2006/main" type="title">
+  <p:cSld name="Title Slide">
+    <p:spTree>
+      <p:nvGrpSpPr>
+        <p:cNvPr id="1" name=""/>
+        <p:cNvGrpSpPr/>
+        <p:nvPr/>
+      </p:nvGrpSpPr>
+      <p:grpSpPr>
+        <a:xfrm>
+          <a:off x="0" y="0"/>
+          <a:ext cx="0" cy="0"/>
+          <a:chOff x="0" y="0"/>
+          <a:chExt cx="0" cy="0"/>
+        </a:xfrm>
+      </p:grpSpPr>
+      <p:sp>
+        <p:nvSpPr>
+          <p:cNvPr id="2" name="Title 1"/>
+          <p:cNvSpPr>
+            <a:spLocks noGrp="1"/>
+          </p:cNvSpPr>
+          <p:nvPr>
+            <p:ph type="ctrTitle"/>
+          </p:nvPr>
+        </p:nvSpPr>
+        <p:spPr>
+          <a:xfrm>
+            <a:off x="914400" y="2130428"/>
+            <a:ext cx="10363200" cy="1470025"/>
+          </a:xfrm>
+        </p:spPr>
+        <p:txBody>
+          <a:bodyPr/>
+          <a:lstStyle/>
+          <a:p>
+            <a:r>
+              <a:rPr lang="en-US"/>
+              <a:t>Click to edit Master title style</a:t>
+            </a:r>
+          </a:p>
+        </p:txBody>
+      </p:sp>
+      <p:sp>
+        <p:nvSpPr>
+          <p:cNvPr id="3" name="Subtitle 2"/>
+          <p:cNvSpPr>
+            <a:spLocks noGrp="1"/>
+          </p:cNvSpPr>
+          <p:nvPr>
+            <p:ph type="subTitle" idx="1"/>
+          </p:nvPr>
+        </p:nvSpPr>
+        <p:spPr>
+          <a:xfrm>
+            <a:off x="1828800" y="3886200"/>
+            <a:ext cx="8534400" cy="1752600"/>
+          </a:xfrm>
+        </p:spPr>
+        <p:txBody>
+          <a:bodyPr/>
+          <a:lstStyle>
+            <a:lvl1pPr marL="0" indent="0" algn="ctr">
+              <a:buNone/>
+              <a:defRPr>
+                <a:solidFill>
+                  <a:schemeClr val="tx1">
+                    <a:tint val="75000"/>
+                  </a:schemeClr>
+                </a:solidFill>
+              </a:defRPr>
+            </a:lvl1pPr>
+            <a:lvl2pPr marL="457200" indent="0" algn="ctr">
+              <a:buNone/>
+              <a:defRPr>
+                <a:solidFill>
+                  <a:schemeClr val="tx1">
+                    <a:tint val="75000"/>
+                  </a:schemeClr>
+                </a:solidFill>
+              </a:defRPr>
+            </a:lvl2pPr>
+            <a:lvl3pPr marL="914400" indent="0" algn="ctr">
+              <a:buNone/>
+              <a:defRPr>
+                <a:solidFill>
+                  <a:schemeClr val="tx1">
+                    <a:tint val="75000"/>
+                  </a:schemeClr>
+                </a:solidFill>
+              </a:defRPr>
+            </a:lvl3pPr>
+            <a:lvl4pPr marL="1371600" indent="0" algn="ctr">
+              <a:buNone/>
+              <a:defRPr>
+                <a:solidFill>
+                  <a:schemeClr val="tx1">
+                    <a:tint val="75000"/>
+                  </a:schemeClr>
+                </a:solidFill>
+              </a:defRPr>
+            </a:lvl4pPr>
+            <a:lvl5pPr marL="1828800" indent="0" algn="ctr">
+              <a:buNone/>
+              <a:defRPr>
+                <a:solidFill>
+                  <a:schemeClr val="tx1">
+                    <a:tint val="75000"/>
+                  </a:schemeClr>
+                </a:solidFill>
+              </a:defRPr>
+            </a:lvl5pPr>
+            <a:lvl6pPr marL="2286000" indent="0" algn="ctr">
+              <a:buNone/>
+              <a:defRPr>
+                <a:solidFill>
+                  <a:schemeClr val="tx1">
+                    <a:tint val="75000"/>
+                  </a:schemeClr>
+                </a:solidFill>
+              </a:defRPr>
+            </a:lvl6pPr>
+            <a:lvl7pPr marL="2743200" indent="0" algn="ctr">
+              <a:buNone/>
+              <a:defRPr>
+                <a:solidFill>
+                  <a:schemeClr val="tx1">
+                    <a:tint val="75000"/>
+                  </a:schemeClr>
+                </a:solidFill>
+              </a:defRPr>
+            </a:lvl7pPr>
+            <a:lvl8pPr marL="3200400" indent="0" algn="ctr">
+              <a:buNone/>
+              <a:defRPr>
+                <a:solidFill>
+                  <a:schemeClr val="tx1">
+                    <a:tint val="75000"/>
+                  </a:schemeClr>
+                </a:solidFill>
+              </a:defRPr>
+            </a:lvl8pPr>
+            <a:lvl9pPr marL="3657600" indent="0" algn="ctr">
+              <a:buNone/>
+              <a:defRPr>
+                <a:solidFill>
+                  <a:schemeClr val="tx1">
+                    <a:tint val="75000"/>
+                  </a:schemeClr>
+                </a:solidFill>
+              </a:defRPr>
+            </a:lvl9pPr>
+          </a:lstStyle>
+          <a:p>
+            <a:r>
+              <a:rPr lang="en-US"/>
+              <a:t>Click to edit Master subtitle style</a:t>
+            </a:r>
+          </a:p>
+        </p:txBody>
+      </p:sp>
+      <p:sp>
+        <p:nvSpPr>
+          <p:cNvPr id="4" name="Date Placeholder 3"/>
+          <p:cNvSpPr>
+            <a:spLocks noGrp="1"/>
+          </p:cNvSpPr>
+          <p:nvPr>
+            <p:ph type="dt" sz="half" idx="10"/>
+          </p:nvPr>
+        </p:nvSpPr>
+        <p:spPr/>
+        <p:txBody>
+          <a:bodyPr/>
+          <a:lstStyle>
+            <a:lvl1pPr>
+              <a:defRPr/>
+            </a:lvl1pPr>
+          </a:lstStyle>
+          <a:p>
+            <a:fld id="{E60792E3-D524-454C-8AFD-A91972900BCB}" type="datetime1">
+              <a:rPr lang="en-US" smtClean="0"/>
+              <a:t>9/19/2026</a:t>
+            </a:fld>
+            <a:endParaRPr lang="en-US"/>
+          </a:p>
+        </p:txBody>
+      </p:sp>
+      <p:sp>
+        <p:nvSpPr>
+          <p:cNvPr id="5" name="Footer Placeholder 4"/>
+          <p:cNvSpPr>
+            <a:spLocks noGrp="1"/>
+          </p:cNvSpPr>
+          <p:nvPr>
+            <p:ph type="ftr" sz="quarter" idx="11"/>
+          </p:nvPr>
+        </p:nvSpPr>
+        <p:spPr/>
+        <p:txBody>
+          <a:bodyPr/>
+          <a:lstStyle>
+            <a:lvl1pPr>
+              <a:defRPr/>
+            </a:lvl1pPr>
+          </a:lstStyle>
+          <a:p>
+            <a:pPr>
+              <a:defRPr/>
+            </a:pPr>
+            <a:r>
+              <a:rPr lang="en-US"/>
+              <a:t>@SIH Idea submission- Template</a:t>
+            </a:r>
+          </a:p>
+        </p:txBody>
+      </p:sp>
+      <p:sp>
+        <p:nvSpPr>
+          <p:cNvPr id="6" name="Slide Number Placeholder 5"/>
+          <p:cNvSpPr>
+            <a:spLocks noGrp="1"/>
+          </p:cNvSpPr>
+          <p:nvPr>
+            <p:ph type="sldNum" sz="quarter" idx="12"/>
+          </p:nvPr>
+        </p:nvSpPr>
+        <p:spPr/>
+        <p:txBody>
+          <a:bodyPr/>
+          <a:lstStyle>
+            <a:lvl1pPr>
+              <a:defRPr/>
+            </a:lvl1pPr>
+          </a:lstStyle>
+          <a:p>
+            <a:fld id="{5B7E1BAA-A38D-40DE-B22C-DF9BD7D82058}" type="slidenum">
+              <a:rPr lang="en-US"/>
+              <a:pPr/>
+              <a:t>‹#›</a:t>
+            </a:fld>
+            <a:endParaRPr lang="en-US"/>
+          </a:p>
+        </p:txBody>
+      </p:sp>
+    </p:spTree>
+    <p:extLst>
+      <p:ext uri="{BB962C8B-B14F-4D97-AF65-F5344CB8AC3E}">
+        <p14:creationId xmlns:p14="http://schemas.microsoft.com/office/powerpoint/2010/main" val="3255363103"/>
+      </p:ext>
+    </p:extLst>
+  </p:cSld>
+  <p:clrMapOvr>
+    <a:masterClrMapping/>
+  </p:clrMapOvr>
+</p:sldLayout>
+</file>
+
 <file path=ppt/slideMasters/slideMaster1.xml><?xml version="1.0" encoding="utf-8"?>
 <p:sldMaster xmlns:a="http://schemas.openxmlformats.org/drawingml/2006/main" xmlns:r="http://schemas.openxmlformats.org/officeDocument/2006/relationships" xmlns:p="http://schemas.openxmlformats.org/presentationml/2006/main">
   <p:cSld>
+    <p:bg>
+      <p:bgRef idx="1001">
+        <a:schemeClr val="bg1"/>
+      </p:bgRef>
+    </p:bg>
     <p:spTree>
       <p:nvGrpSpPr>
         <p:cNvPr id="1" name=""/>
@@ -1041,6 +978,7 @@
   <p:clrMap bg1="lt1" tx1="dk1" bg2="lt2" tx2="dk2" accent1="accent1" accent2="accent2" accent3="accent3" accent4="accent4" accent5="accent5" accent6="accent6" hlink="hlink" folHlink="folHlink"/>
   <p:sldLayoutIdLst>
     <p:sldLayoutId id="2147483649" r:id="rId1"/>
+    <p:sldLayoutId id="2147483650" r:id="rId2"/>
   </p:sldLayoutIdLst>
   <p:hf sldNum="0" hdr="0" ftr="0" dt="0"/>
   <p:txStyles>
@@ -1298,12 +1236,348 @@
 
 <file path=ppt/slides/slide1.xml><?xml version="1.0" encoding="utf-8"?>
 <p:sld xmlns:a="http://schemas.openxmlformats.org/drawingml/2006/main" xmlns:r="http://schemas.openxmlformats.org/officeDocument/2006/relationships" xmlns:p="http://schemas.openxmlformats.org/presentationml/2006/main">
-  <p:cSld name="Slide 1">
+  <p:cSld>
+    <p:spTree>
+      <p:nvGrpSpPr>
+        <p:cNvPr id="1" name=""/>
+        <p:cNvGrpSpPr/>
+        <p:nvPr/>
+      </p:nvGrpSpPr>
+      <p:grpSpPr>
+        <a:xfrm>
+          <a:off x="0" y="0"/>
+          <a:ext cx="0" cy="0"/>
+          <a:chOff x="0" y="0"/>
+          <a:chExt cx="0" cy="0"/>
+        </a:xfrm>
+      </p:grpSpPr>
+      <p:pic>
+        <p:nvPicPr>
+          <p:cNvPr id="5" name="Picture 4">
+            <a:extLst>
+              <a:ext uri="{FF2B5EF4-FFF2-40B4-BE49-F238E27FC236}">
+                <a16:creationId xmlns:a16="http://schemas.microsoft.com/office/drawing/2014/main" id="{9120848B-B2B4-45BE-A961-AEC0B06CF41B}"/>
+              </a:ext>
+            </a:extLst>
+          </p:cNvPr>
+          <p:cNvPicPr>
+            <a:picLocks noChangeAspect="1"/>
+          </p:cNvPicPr>
+          <p:nvPr/>
+        </p:nvPicPr>
+        <p:blipFill rotWithShape="1">
+          <a:blip r:embed="rId2"/>
+          <a:srcRect r="59916"/>
+          <a:stretch/>
+        </p:blipFill>
+        <p:spPr>
+          <a:xfrm>
+            <a:off x="6854891" y="1715881"/>
+            <a:ext cx="3203509" cy="3426237"/>
+          </a:xfrm>
+          <a:prstGeom prst="rect">
+            <a:avLst/>
+          </a:prstGeom>
+        </p:spPr>
+      </p:pic>
+      <p:sp>
+        <p:nvSpPr>
+          <p:cNvPr id="4" name="Subtitle 3"/>
+          <p:cNvSpPr>
+            <a:spLocks noGrp="1"/>
+          </p:cNvSpPr>
+          <p:nvPr>
+            <p:ph type="subTitle" idx="1"/>
+          </p:nvPr>
+        </p:nvSpPr>
+        <p:spPr>
+          <a:xfrm>
+            <a:off x="1245686" y="648614"/>
+            <a:ext cx="8534400" cy="1752600"/>
+          </a:xfrm>
+        </p:spPr>
+        <p:txBody>
+          <a:bodyPr/>
+          <a:lstStyle/>
+          <a:p>
+            <a:endParaRPr lang="en-US" b="1" dirty="0">
+              <a:solidFill>
+                <a:schemeClr val="tx1"/>
+              </a:solidFill>
+              <a:latin typeface="Times New Roman" panose="02020603050405020304" pitchFamily="18" charset="0"/>
+              <a:cs typeface="Times New Roman" panose="02020603050405020304" pitchFamily="18" charset="0"/>
+            </a:endParaRPr>
+          </a:p>
+          <a:p>
+            <a:r>
+              <a:rPr lang="en-US" b="1" dirty="0">
+                <a:solidFill>
+                  <a:schemeClr val="tx1"/>
+                </a:solidFill>
+                <a:latin typeface="Times New Roman" panose="02020603050405020304" pitchFamily="18" charset="0"/>
+                <a:cs typeface="Times New Roman" panose="02020603050405020304" pitchFamily="18" charset="0"/>
+              </a:rPr>
+              <a:t>TITLE PAGE</a:t>
+            </a:r>
+            <a:endParaRPr lang="en-IN" b="1" dirty="0">
+              <a:solidFill>
+                <a:schemeClr val="tx1"/>
+              </a:solidFill>
+              <a:latin typeface="Times New Roman" panose="02020603050405020304" pitchFamily="18" charset="0"/>
+              <a:cs typeface="Times New Roman" panose="02020603050405020304" pitchFamily="18" charset="0"/>
+            </a:endParaRPr>
+          </a:p>
+        </p:txBody>
+      </p:sp>
+      <p:sp>
+        <p:nvSpPr>
+          <p:cNvPr id="8" name="Title 7"/>
+          <p:cNvSpPr>
+            <a:spLocks noGrp="1"/>
+          </p:cNvSpPr>
+          <p:nvPr>
+            <p:ph type="ctrTitle"/>
+          </p:nvPr>
+        </p:nvSpPr>
+        <p:spPr>
+          <a:xfrm>
+            <a:off x="331286" y="-526757"/>
+            <a:ext cx="10363200" cy="2076450"/>
+          </a:xfrm>
+        </p:spPr>
+        <p:txBody>
+          <a:bodyPr/>
+          <a:lstStyle/>
+          <a:p>
+            <a:pPr>
+              <a:defRPr sz="4000" b="1">
+                <a:latin typeface="Garamond"/>
+              </a:defRPr>
+            </a:pPr>
+            <a:r>
+              <a:t>SMART INDIA HACKATHON 2026</a:t>
+            </a:r>
+            <a:endParaRPr lang="en-IN" sz="4000" b="1" dirty="0">
+              <a:solidFill>
+                <a:schemeClr val="tx2"/>
+              </a:solidFill>
+              <a:latin typeface="Garamond" panose="02020404030301010803" pitchFamily="18" charset="0"/>
+            </a:endParaRPr>
+          </a:p>
+        </p:txBody>
+      </p:sp>
+      <p:sp>
+        <p:nvSpPr>
+          <p:cNvPr id="10" name="TextBox 9"/>
+          <p:cNvSpPr txBox="1"/>
+          <p:nvPr/>
+        </p:nvSpPr>
+        <p:spPr>
+          <a:xfrm>
+            <a:off x="557726" y="1919814"/>
+            <a:ext cx="5924550" cy="3836948"/>
+          </a:xfrm>
+          <a:prstGeom prst="rect">
+            <a:avLst/>
+          </a:prstGeom>
+          <a:noFill/>
+        </p:spPr>
+        <p:txBody>
+          <a:bodyPr wrap="square" rtlCol="0">
+            <a:spAutoFit/>
+          </a:bodyPr>
+          <a:lstStyle/>
+          <a:p>
+            <a:pPr>
+              <a:spcAft>
+                <a:spcPts val="800"/>
+              </a:spcAft>
+              <a:defRPr sz="1900" b="1">
+                <a:latin typeface="Arial"/>
+              </a:defRPr>
+            </a:pPr>
+            <a:r>
+              <a:rPr dirty="0"/>
+              <a:t>Problem Statement ID – SIH26120</a:t>
+            </a:r>
+            <a:endParaRPr lang="en-IN" dirty="0"/>
+          </a:p>
+          <a:p>
+            <a:pPr>
+              <a:spcAft>
+                <a:spcPts val="800"/>
+              </a:spcAft>
+              <a:defRPr sz="1900" b="1">
+                <a:latin typeface="Arial"/>
+              </a:defRPr>
+            </a:pPr>
+            <a:endParaRPr lang="en-US" dirty="0"/>
+          </a:p>
+          <a:p>
+            <a:pPr>
+              <a:spcAft>
+                <a:spcPts val="800"/>
+              </a:spcAft>
+              <a:defRPr sz="1900" b="0">
+                <a:latin typeface="Arial"/>
+              </a:defRPr>
+            </a:pPr>
+            <a:r>
+              <a:rPr b="1" i="1" u="sng" dirty="0"/>
+              <a:t>Problem Statement Title </a:t>
+            </a:r>
+            <a:r>
+              <a:rPr dirty="0"/>
+              <a:t>– Digital Twin for Well-to-Surface Optimization of CSS and SRP Operations</a:t>
+            </a:r>
+            <a:endParaRPr lang="en-IN" dirty="0"/>
+          </a:p>
+          <a:p>
+            <a:pPr>
+              <a:spcAft>
+                <a:spcPts val="800"/>
+              </a:spcAft>
+              <a:defRPr sz="1900" b="0">
+                <a:latin typeface="Arial"/>
+              </a:defRPr>
+            </a:pPr>
+            <a:endParaRPr dirty="0"/>
+          </a:p>
+          <a:p>
+            <a:pPr>
+              <a:spcAft>
+                <a:spcPts val="800"/>
+              </a:spcAft>
+              <a:defRPr sz="1900" b="0">
+                <a:latin typeface="Arial"/>
+              </a:defRPr>
+            </a:pPr>
+            <a:r>
+              <a:rPr b="1" i="1" u="sng" dirty="0"/>
+              <a:t>Theme </a:t>
+            </a:r>
+            <a:r>
+              <a:rPr dirty="0"/>
+              <a:t>– </a:t>
+            </a:r>
+            <a:r>
+              <a:rPr lang="en-IN" dirty="0"/>
+              <a:t>Smart Automation</a:t>
+            </a:r>
+          </a:p>
+          <a:p>
+            <a:pPr>
+              <a:spcAft>
+                <a:spcPts val="800"/>
+              </a:spcAft>
+              <a:defRPr sz="1900" b="0">
+                <a:latin typeface="Arial"/>
+              </a:defRPr>
+            </a:pPr>
+            <a:endParaRPr dirty="0"/>
+          </a:p>
+          <a:p>
+            <a:pPr>
+              <a:spcAft>
+                <a:spcPts val="800"/>
+              </a:spcAft>
+              <a:defRPr sz="1900" b="0">
+                <a:latin typeface="Arial"/>
+              </a:defRPr>
+            </a:pPr>
+            <a:r>
+              <a:rPr b="1" i="1" u="sng" dirty="0"/>
+              <a:t>PS Category </a:t>
+            </a:r>
+            <a:r>
+              <a:rPr dirty="0"/>
+              <a:t>– Software</a:t>
+            </a:r>
+            <a:endParaRPr lang="en-IN" dirty="0"/>
+          </a:p>
+          <a:p>
+            <a:pPr>
+              <a:spcAft>
+                <a:spcPts val="800"/>
+              </a:spcAft>
+              <a:defRPr sz="1900" b="0">
+                <a:latin typeface="Arial"/>
+              </a:defRPr>
+            </a:pPr>
+            <a:endParaRPr dirty="0"/>
+          </a:p>
+          <a:p>
+            <a:pPr>
+              <a:spcAft>
+                <a:spcPts val="800"/>
+              </a:spcAft>
+              <a:defRPr sz="1900" b="0">
+                <a:latin typeface="Arial"/>
+              </a:defRPr>
+            </a:pPr>
+            <a:r>
+              <a:rPr b="1" i="1" u="sng" dirty="0"/>
+              <a:t>Team Name</a:t>
+            </a:r>
+            <a:r>
+              <a:rPr dirty="0"/>
+              <a:t> – </a:t>
+            </a:r>
+            <a:r>
+              <a:rPr lang="en-IN" dirty="0" err="1"/>
+              <a:t>CosmicRift</a:t>
+            </a:r>
+            <a:endParaRPr dirty="0"/>
+          </a:p>
+        </p:txBody>
+      </p:sp>
+      <p:pic>
+        <p:nvPicPr>
+          <p:cNvPr id="2" name="Picture 1"/>
+          <p:cNvPicPr>
+            <a:picLocks noChangeAspect="1"/>
+          </p:cNvPicPr>
+          <p:nvPr/>
+        </p:nvPicPr>
+        <p:blipFill>
+          <a:blip r:embed="rId3">
+            <a:extLst>
+              <a:ext uri="{28A0092B-C50C-407E-A947-70E740481C1C}">
+                <a14:useLocalDpi xmlns:a14="http://schemas.microsoft.com/office/drawing/2010/main" val="0"/>
+              </a:ext>
+            </a:extLst>
+          </a:blip>
+          <a:stretch>
+            <a:fillRect/>
+          </a:stretch>
+        </p:blipFill>
+        <p:spPr>
+          <a:xfrm>
+            <a:off x="9780086" y="1500"/>
+            <a:ext cx="2249850" cy="1062337"/>
+          </a:xfrm>
+          <a:prstGeom prst="rect">
+            <a:avLst/>
+          </a:prstGeom>
+        </p:spPr>
+      </p:pic>
+    </p:spTree>
+  </p:cSld>
+  <p:clrMapOvr>
+    <a:masterClrMapping/>
+  </p:clrMapOvr>
+</p:sld>
+</file>
+
+<file path=ppt/slides/slide2.xml><?xml version="1.0" encoding="utf-8"?>
+<p:sld xmlns:a="http://schemas.openxmlformats.org/drawingml/2006/main" xmlns:r="http://schemas.openxmlformats.org/officeDocument/2006/relationships" xmlns:p="http://schemas.openxmlformats.org/presentationml/2006/main">
+  <p:cSld name="Slide 2">
     <p:bg>
       <p:bgPr>
         <a:solidFill>
           <a:srgbClr val="FFFFFF"/>
         </a:solidFill>
+        <a:effectLst/>
       </p:bgPr>
     </p:bg>
     <p:spTree>
@@ -1328,8 +1602,8 @@
         </p:nvSpPr>
         <p:spPr>
           <a:xfrm>
-            <a:off x="3840480" y="914400"/>
-            <a:ext cx="4572000" cy="365760"/>
+            <a:off x="548640" y="320040"/>
+            <a:ext cx="3657600" cy="274320"/>
           </a:xfrm>
           <a:prstGeom prst="rect">
             <a:avLst/>
@@ -1341,11 +1615,11 @@
           <a:bodyPr wrap="square" rtlCol="0" anchor="ctr"/>
           <a:lstStyle/>
           <a:p>
-            <a:pPr algn="ctr" indent="0" marL="0">
+            <a:pPr marL="0" indent="0">
               <a:buNone/>
             </a:pPr>
             <a:r>
-              <a:rPr lang="en-US" sz="1600" b="1" dirty="0">
+              <a:rPr lang="en-US" sz="1100" b="1" dirty="0">
                 <a:solidFill>
                   <a:srgbClr val="D97706"/>
                 </a:solidFill>
@@ -1355,7 +1629,7 @@
               </a:rPr>
               <a:t>Smart India Hackathon 2026</a:t>
             </a:r>
-            <a:endParaRPr lang="en-US" sz="1600" dirty="0"/>
+            <a:endParaRPr lang="en-US" sz="1100" dirty="0"/>
           </a:p>
         </p:txBody>
       </p:sp>
@@ -1367,8 +1641,8 @@
         </p:nvSpPr>
         <p:spPr>
           <a:xfrm>
-            <a:off x="731520" y="1828800"/>
-            <a:ext cx="10515600" cy="457200"/>
+            <a:off x="548640" y="640080"/>
+            <a:ext cx="9144000" cy="548640"/>
           </a:xfrm>
           <a:prstGeom prst="rect">
             <a:avLst/>
@@ -1380,48 +1654,73 @@
           <a:bodyPr wrap="square" rtlCol="0" anchor="ctr"/>
           <a:lstStyle/>
           <a:p>
-            <a:pPr indent="0" marL="0">
+            <a:pPr marL="0" indent="0">
               <a:buNone/>
             </a:pPr>
             <a:r>
-              <a:rPr lang="en-US" sz="1500" b="1" dirty="0">
-                <a:solidFill>
-                  <a:srgbClr val="0F172A"/>
-                </a:solidFill>
-                <a:latin typeface="Calibri" pitchFamily="34" charset="0"/>
-                <a:ea typeface="Calibri" pitchFamily="34" charset="-122"/>
-                <a:cs typeface="Calibri" pitchFamily="34" charset="-120"/>
-              </a:rPr>
-              <a:t>Problem Statement ID </a:t>
-            </a:r>
-            <a:pPr indent="0" marL="0">
+              <a:rPr lang="en-US" sz="2400" b="1" dirty="0">
+                <a:solidFill>
+                  <a:srgbClr val="1E3A8A"/>
+                </a:solidFill>
+                <a:latin typeface="Arial Black" pitchFamily="34" charset="0"/>
+                <a:ea typeface="Arial Black" pitchFamily="34" charset="-122"/>
+                <a:cs typeface="Arial Black" pitchFamily="34" charset="-120"/>
+              </a:rPr>
+              <a:t>PROPOSED SOLUTION</a:t>
+            </a:r>
+            <a:endParaRPr lang="en-US" sz="2400" dirty="0"/>
+          </a:p>
+        </p:txBody>
+      </p:sp>
+      <p:sp>
+        <p:nvSpPr>
+          <p:cNvPr id="4" name="Text 2"/>
+          <p:cNvSpPr/>
+          <p:nvPr/>
+        </p:nvSpPr>
+        <p:spPr>
+          <a:xfrm>
+            <a:off x="548640" y="6309360"/>
+            <a:ext cx="3657600" cy="274320"/>
+          </a:xfrm>
+          <a:prstGeom prst="rect">
+            <a:avLst/>
+          </a:prstGeom>
+          <a:noFill/>
+          <a:ln/>
+        </p:spPr>
+        <p:txBody>
+          <a:bodyPr wrap="square" rtlCol="0" anchor="ctr"/>
+          <a:lstStyle/>
+          <a:p>
+            <a:pPr marL="0" indent="0">
               <a:buNone/>
             </a:pPr>
             <a:r>
-              <a:rPr lang="en-US" sz="1500" dirty="0">
-                <a:solidFill>
-                  <a:srgbClr val="1E293B"/>
-                </a:solidFill>
-                <a:latin typeface="Calibri" pitchFamily="34" charset="0"/>
-                <a:ea typeface="Calibri" pitchFamily="34" charset="-122"/>
-                <a:cs typeface="Calibri" pitchFamily="34" charset="-120"/>
-              </a:rPr>
-              <a:t>– SIH26120</a:t>
-            </a:r>
-            <a:endParaRPr lang="en-US" sz="1500" dirty="0"/>
-          </a:p>
-        </p:txBody>
-      </p:sp>
-      <p:sp>
-        <p:nvSpPr>
-          <p:cNvPr id="4" name="Text 2"/>
+              <a:rPr lang="en-US" sz="900" dirty="0">
+                <a:solidFill>
+                  <a:srgbClr val="64748B"/>
+                </a:solidFill>
+                <a:latin typeface="Arial" pitchFamily="34" charset="0"/>
+                <a:ea typeface="Arial" pitchFamily="34" charset="-122"/>
+                <a:cs typeface="Arial" pitchFamily="34" charset="-120"/>
+              </a:rPr>
+              <a:t>2 @SIH Idea submission-Template</a:t>
+            </a:r>
+            <a:endParaRPr lang="en-US" sz="900" dirty="0"/>
+          </a:p>
+        </p:txBody>
+      </p:sp>
+      <p:sp>
+        <p:nvSpPr>
+          <p:cNvPr id="5" name="Text 3"/>
           <p:cNvSpPr/>
           <p:nvPr/>
         </p:nvSpPr>
         <p:spPr>
           <a:xfrm>
-            <a:off x="731520" y="2423160"/>
-            <a:ext cx="10515600" cy="457200"/>
+            <a:off x="9144000" y="6309360"/>
+            <a:ext cx="2468880" cy="274320"/>
           </a:xfrm>
           <a:prstGeom prst="rect">
             <a:avLst/>
@@ -1433,48 +1732,100 @@
           <a:bodyPr wrap="square" rtlCol="0" anchor="ctr"/>
           <a:lstStyle/>
           <a:p>
-            <a:pPr indent="0" marL="0">
+            <a:pPr marL="0" indent="0" algn="r">
               <a:buNone/>
             </a:pPr>
             <a:r>
-              <a:rPr lang="en-US" sz="1500" b="1" dirty="0">
-                <a:solidFill>
-                  <a:srgbClr val="0F172A"/>
-                </a:solidFill>
-                <a:latin typeface="Calibri" pitchFamily="34" charset="0"/>
-                <a:ea typeface="Calibri" pitchFamily="34" charset="-122"/>
-                <a:cs typeface="Calibri" pitchFamily="34" charset="-120"/>
-              </a:rPr>
-              <a:t>Problem Statement Title </a:t>
-            </a:r>
-            <a:pPr indent="0" marL="0">
+              <a:rPr lang="en-US" sz="900" dirty="0">
+                <a:solidFill>
+                  <a:srgbClr val="64748B"/>
+                </a:solidFill>
+                <a:latin typeface="Arial" pitchFamily="34" charset="0"/>
+                <a:ea typeface="Arial" pitchFamily="34" charset="-122"/>
+                <a:cs typeface="Arial" pitchFamily="34" charset="-120"/>
+              </a:rPr>
+              <a:t>[Enter Your Team Name]</a:t>
+            </a:r>
+            <a:endParaRPr lang="en-US" sz="900" dirty="0"/>
+          </a:p>
+        </p:txBody>
+      </p:sp>
+      <p:sp>
+        <p:nvSpPr>
+          <p:cNvPr id="6" name="Shape 4"/>
+          <p:cNvSpPr/>
+          <p:nvPr/>
+        </p:nvSpPr>
+        <p:spPr>
+          <a:xfrm>
+            <a:off x="548640" y="1280160"/>
+            <a:ext cx="5303520" cy="4846320"/>
+          </a:xfrm>
+          <a:prstGeom prst="roundRect">
+            <a:avLst>
+              <a:gd name="adj" fmla="val 1887"/>
+            </a:avLst>
+          </a:prstGeom>
+          <a:solidFill>
+            <a:srgbClr val="F8FAFC"/>
+          </a:solidFill>
+          <a:ln w="12700">
+            <a:solidFill>
+              <a:srgbClr val="E2E8F0"/>
+            </a:solidFill>
+            <a:prstDash val="solid"/>
+          </a:ln>
+        </p:spPr>
+      </p:sp>
+      <p:sp>
+        <p:nvSpPr>
+          <p:cNvPr id="7" name="Text 5"/>
+          <p:cNvSpPr/>
+          <p:nvPr/>
+        </p:nvSpPr>
+        <p:spPr>
+          <a:xfrm>
+            <a:off x="731520" y="1417320"/>
+            <a:ext cx="4937760" cy="320040"/>
+          </a:xfrm>
+          <a:prstGeom prst="rect">
+            <a:avLst/>
+          </a:prstGeom>
+          <a:noFill/>
+          <a:ln/>
+        </p:spPr>
+        <p:txBody>
+          <a:bodyPr wrap="square" rtlCol="0" anchor="ctr"/>
+          <a:lstStyle/>
+          <a:p>
+            <a:pPr marL="0" indent="0">
               <a:buNone/>
             </a:pPr>
             <a:r>
-              <a:rPr lang="en-US" sz="1500" dirty="0">
-                <a:solidFill>
-                  <a:srgbClr val="1E293B"/>
-                </a:solidFill>
-                <a:latin typeface="Calibri" pitchFamily="34" charset="0"/>
-                <a:ea typeface="Calibri" pitchFamily="34" charset="-122"/>
-                <a:cs typeface="Calibri" pitchFamily="34" charset="-120"/>
-              </a:rPr>
-              <a:t>- Digital Twin for Well-to-Surface Optimization of CSS and SRP Operations</a:t>
-            </a:r>
-            <a:endParaRPr lang="en-US" sz="1500" dirty="0"/>
-          </a:p>
-        </p:txBody>
-      </p:sp>
-      <p:sp>
-        <p:nvSpPr>
-          <p:cNvPr id="5" name="Text 3"/>
+              <a:rPr lang="en-US" sz="1300" b="1" dirty="0">
+                <a:solidFill>
+                  <a:srgbClr val="991B1B"/>
+                </a:solidFill>
+                <a:latin typeface="Arial" pitchFamily="34" charset="0"/>
+                <a:ea typeface="Arial" pitchFamily="34" charset="-122"/>
+                <a:cs typeface="Arial" pitchFamily="34" charset="-120"/>
+              </a:rPr>
+              <a:t>PROBLEM STATEMENT &amp; CHALLENGES</a:t>
+            </a:r>
+            <a:endParaRPr lang="en-US" sz="1300" dirty="0"/>
+          </a:p>
+        </p:txBody>
+      </p:sp>
+      <p:sp>
+        <p:nvSpPr>
+          <p:cNvPr id="8" name="Text 6"/>
           <p:cNvSpPr/>
           <p:nvPr/>
         </p:nvSpPr>
         <p:spPr>
           <a:xfrm>
-            <a:off x="731520" y="3017520"/>
-            <a:ext cx="10515600" cy="457200"/>
+            <a:off x="731520" y="1828800"/>
+            <a:ext cx="4937760" cy="4114800"/>
           </a:xfrm>
           <a:prstGeom prst="rect">
             <a:avLst/>
@@ -1486,11 +1837,11 @@
           <a:bodyPr wrap="square" rtlCol="0" anchor="ctr"/>
           <a:lstStyle/>
           <a:p>
-            <a:pPr indent="0" marL="0">
+            <a:pPr marL="0" indent="0">
               <a:buNone/>
             </a:pPr>
             <a:r>
-              <a:rPr lang="en-US" sz="1500" b="1" dirty="0">
+              <a:rPr lang="en-US" sz="1150" b="1" dirty="0">
                 <a:solidFill>
                   <a:srgbClr val="0F172A"/>
                 </a:solidFill>
@@ -1498,36 +1849,172 @@
                 <a:ea typeface="Calibri" pitchFamily="34" charset="-122"/>
                 <a:cs typeface="Calibri" pitchFamily="34" charset="-120"/>
               </a:rPr>
-              <a:t>Theme </a:t>
-            </a:r>
-            <a:pPr indent="0" marL="0">
+              <a:t>• Blind Subsurface Operations:
+</a:t>
+            </a:r>
+            <a:r>
+              <a:rPr lang="en-US" sz="1100" dirty="0">
+                <a:solidFill>
+                  <a:srgbClr val="334155"/>
+                </a:solidFill>
+                <a:latin typeface="Calibri" pitchFamily="34" charset="0"/>
+                <a:ea typeface="Calibri" pitchFamily="34" charset="-122"/>
+                <a:cs typeface="Calibri" pitchFamily="34" charset="-120"/>
+              </a:rPr>
+              <a:t>  Zero real-time visibility into deepwater wellhead dynamics, downhole PDC drill torque, and multi-phase flow lines.
+</a:t>
+            </a:r>
+            <a:r>
+              <a:rPr lang="en-US" sz="1150" b="1" dirty="0">
+                <a:solidFill>
+                  <a:srgbClr val="0F172A"/>
+                </a:solidFill>
+                <a:latin typeface="Calibri" pitchFamily="34" charset="0"/>
+                <a:ea typeface="Calibri" pitchFamily="34" charset="-122"/>
+                <a:cs typeface="Calibri" pitchFamily="34" charset="-120"/>
+              </a:rPr>
+              <a:t>• Costly Unscheduled Downtime:
+</a:t>
+            </a:r>
+            <a:r>
+              <a:rPr lang="en-US" sz="1100" dirty="0">
+                <a:solidFill>
+                  <a:srgbClr val="334155"/>
+                </a:solidFill>
+                <a:latin typeface="Calibri" pitchFamily="34" charset="0"/>
+                <a:ea typeface="Calibri" pitchFamily="34" charset="-122"/>
+                <a:cs typeface="Calibri" pitchFamily="34" charset="-120"/>
+              </a:rPr>
+              <a:t>  Reactive maintenance leads to catastrophic pump failures, stuck pipe incidents, and ₹25L+ losses per event.
+</a:t>
+            </a:r>
+            <a:r>
+              <a:rPr lang="en-US" sz="1150" b="1" dirty="0">
+                <a:solidFill>
+                  <a:srgbClr val="0F172A"/>
+                </a:solidFill>
+                <a:latin typeface="Calibri" pitchFamily="34" charset="0"/>
+                <a:ea typeface="Calibri" pitchFamily="34" charset="-122"/>
+                <a:cs typeface="Calibri" pitchFamily="34" charset="-120"/>
+              </a:rPr>
+              <a:t>• Undetected Water/Gas Breakthroughs:
+</a:t>
+            </a:r>
+            <a:r>
+              <a:rPr lang="en-US" sz="1100" dirty="0">
+                <a:solidFill>
+                  <a:srgbClr val="334155"/>
+                </a:solidFill>
+                <a:latin typeface="Calibri" pitchFamily="34" charset="0"/>
+                <a:ea typeface="Calibri" pitchFamily="34" charset="-122"/>
+                <a:cs typeface="Calibri" pitchFamily="34" charset="-120"/>
+              </a:rPr>
+              <a:t>  Emulsion surges and hydrate plugs choke subsea flowlines without early warning or ASTM D1250 net oil purification.
+</a:t>
+            </a:r>
+            <a:r>
+              <a:rPr lang="en-US" sz="1150" b="1" dirty="0">
+                <a:solidFill>
+                  <a:srgbClr val="0F172A"/>
+                </a:solidFill>
+                <a:latin typeface="Calibri" pitchFamily="34" charset="0"/>
+                <a:ea typeface="Calibri" pitchFamily="34" charset="-122"/>
+                <a:cs typeface="Calibri" pitchFamily="34" charset="-120"/>
+              </a:rPr>
+              <a:t>• Fragmented Industrial Data:
+</a:t>
+            </a:r>
+            <a:r>
+              <a:rPr lang="en-US" sz="1100" dirty="0">
+                <a:solidFill>
+                  <a:srgbClr val="334155"/>
+                </a:solidFill>
+                <a:latin typeface="Calibri" pitchFamily="34" charset="0"/>
+                <a:ea typeface="Calibri" pitchFamily="34" charset="-122"/>
+                <a:cs typeface="Calibri" pitchFamily="34" charset="-120"/>
+              </a:rPr>
+              <a:t>  Telemetry is siloed across SCADA systems with no 3D spatial twin or automated midnight settlement compliance.</a:t>
+            </a:r>
+            <a:endParaRPr lang="en-US" sz="1150" dirty="0"/>
+          </a:p>
+        </p:txBody>
+      </p:sp>
+      <p:sp>
+        <p:nvSpPr>
+          <p:cNvPr id="9" name="Shape 7"/>
+          <p:cNvSpPr/>
+          <p:nvPr/>
+        </p:nvSpPr>
+        <p:spPr>
+          <a:xfrm>
+            <a:off x="6035040" y="1280160"/>
+            <a:ext cx="5577840" cy="4846320"/>
+          </a:xfrm>
+          <a:prstGeom prst="roundRect">
+            <a:avLst>
+              <a:gd name="adj" fmla="val 1887"/>
+            </a:avLst>
+          </a:prstGeom>
+          <a:solidFill>
+            <a:srgbClr val="F0FDF4"/>
+          </a:solidFill>
+          <a:ln w="12700">
+            <a:solidFill>
+              <a:srgbClr val="BBF7D0"/>
+            </a:solidFill>
+            <a:prstDash val="solid"/>
+          </a:ln>
+        </p:spPr>
+      </p:sp>
+      <p:sp>
+        <p:nvSpPr>
+          <p:cNvPr id="10" name="Text 8"/>
+          <p:cNvSpPr/>
+          <p:nvPr/>
+        </p:nvSpPr>
+        <p:spPr>
+          <a:xfrm>
+            <a:off x="6217920" y="1417320"/>
+            <a:ext cx="5212080" cy="320040"/>
+          </a:xfrm>
+          <a:prstGeom prst="rect">
+            <a:avLst/>
+          </a:prstGeom>
+          <a:noFill/>
+          <a:ln/>
+        </p:spPr>
+        <p:txBody>
+          <a:bodyPr wrap="square" rtlCol="0" anchor="ctr"/>
+          <a:lstStyle/>
+          <a:p>
+            <a:pPr marL="0" indent="0">
               <a:buNone/>
             </a:pPr>
             <a:r>
-              <a:rPr lang="en-US" sz="1500" dirty="0">
-                <a:solidFill>
-                  <a:srgbClr val="1E293B"/>
-                </a:solidFill>
-                <a:latin typeface="Calibri" pitchFamily="34" charset="0"/>
-                <a:ea typeface="Calibri" pitchFamily="34" charset="-122"/>
-                <a:cs typeface="Calibri" pitchFamily="34" charset="-120"/>
-              </a:rPr>
-              <a:t>- Clean &amp; Green Technology</a:t>
-            </a:r>
-            <a:endParaRPr lang="en-US" sz="1500" dirty="0"/>
-          </a:p>
-        </p:txBody>
-      </p:sp>
-      <p:sp>
-        <p:nvSpPr>
-          <p:cNvPr id="6" name="Text 4"/>
+              <a:rPr lang="en-US" sz="1300" b="1" dirty="0">
+                <a:solidFill>
+                  <a:srgbClr val="065F46"/>
+                </a:solidFill>
+                <a:latin typeface="Arial" pitchFamily="34" charset="0"/>
+                <a:ea typeface="Arial" pitchFamily="34" charset="-122"/>
+                <a:cs typeface="Arial" pitchFamily="34" charset="-120"/>
+              </a:rPr>
+              <a:t>PROPOSED SOLUTION (VARUNA-AI)</a:t>
+            </a:r>
+            <a:endParaRPr lang="en-US" sz="1300" dirty="0"/>
+          </a:p>
+        </p:txBody>
+      </p:sp>
+      <p:sp>
+        <p:nvSpPr>
+          <p:cNvPr id="11" name="Text 9"/>
           <p:cNvSpPr/>
           <p:nvPr/>
         </p:nvSpPr>
         <p:spPr>
           <a:xfrm>
-            <a:off x="731520" y="3611880"/>
-            <a:ext cx="10515600" cy="457200"/>
+            <a:off x="6217920" y="1828800"/>
+            <a:ext cx="5212080" cy="4114800"/>
           </a:xfrm>
           <a:prstGeom prst="rect">
             <a:avLst/>
@@ -1539,144 +2026,144 @@
           <a:bodyPr wrap="square" rtlCol="0" anchor="ctr"/>
           <a:lstStyle/>
           <a:p>
-            <a:pPr indent="0" marL="0">
+            <a:pPr marL="0" indent="0">
               <a:buNone/>
             </a:pPr>
             <a:r>
-              <a:rPr lang="en-US" sz="1500" b="1" dirty="0">
-                <a:solidFill>
-                  <a:srgbClr val="0F172A"/>
-                </a:solidFill>
-                <a:latin typeface="Calibri" pitchFamily="34" charset="0"/>
-                <a:ea typeface="Calibri" pitchFamily="34" charset="-122"/>
-                <a:cs typeface="Calibri" pitchFamily="34" charset="-120"/>
-              </a:rPr>
-              <a:t>PS Category </a:t>
-            </a:r>
-            <a:pPr indent="0" marL="0">
-              <a:buNone/>
-            </a:pPr>
-            <a:r>
-              <a:rPr lang="en-US" sz="1500" dirty="0">
-                <a:solidFill>
-                  <a:srgbClr val="1E293B"/>
-                </a:solidFill>
-                <a:latin typeface="Calibri" pitchFamily="34" charset="0"/>
-                <a:ea typeface="Calibri" pitchFamily="34" charset="-122"/>
-                <a:cs typeface="Calibri" pitchFamily="34" charset="-120"/>
-              </a:rPr>
-              <a:t>- Software · IoT + AI/ML</a:t>
-            </a:r>
-            <a:endParaRPr lang="en-US" sz="1500" dirty="0"/>
-          </a:p>
-        </p:txBody>
-      </p:sp>
-      <p:sp>
-        <p:nvSpPr>
-          <p:cNvPr id="7" name="Text 5"/>
-          <p:cNvSpPr/>
-          <p:nvPr/>
-        </p:nvSpPr>
-        <p:spPr>
-          <a:xfrm>
-            <a:off x="731520" y="4206240"/>
-            <a:ext cx="10515600" cy="457200"/>
+              <a:rPr lang="en-US" sz="1150" b="1" dirty="0">
+                <a:solidFill>
+                  <a:srgbClr val="065F46"/>
+                </a:solidFill>
+                <a:latin typeface="Calibri" pitchFamily="34" charset="0"/>
+                <a:ea typeface="Calibri" pitchFamily="34" charset="-122"/>
+                <a:cs typeface="Calibri" pitchFamily="34" charset="-120"/>
+              </a:rPr>
+              <a:t>• 50.0 Hz Physics-Informed Cyber-Twin:
+</a:t>
+            </a:r>
+            <a:r>
+              <a:rPr lang="en-US" sz="1100" dirty="0">
+                <a:solidFill>
+                  <a:srgbClr val="334155"/>
+                </a:solidFill>
+                <a:latin typeface="Calibri" pitchFamily="34" charset="0"/>
+                <a:ea typeface="Calibri" pitchFamily="34" charset="-122"/>
+                <a:cs typeface="Calibri" pitchFamily="34" charset="-120"/>
+              </a:rPr>
+              <a:t>  Real-time subsea-to-topside 3D visualization in WebGL/Three.js with 20ms ultra-fast sensor ingestion.
+</a:t>
+            </a:r>
+            <a:r>
+              <a:rPr lang="en-US" sz="1150" b="1" dirty="0">
+                <a:solidFill>
+                  <a:srgbClr val="065F46"/>
+                </a:solidFill>
+                <a:latin typeface="Calibri" pitchFamily="34" charset="0"/>
+                <a:ea typeface="Calibri" pitchFamily="34" charset="-122"/>
+                <a:cs typeface="Calibri" pitchFamily="34" charset="-120"/>
+              </a:rPr>
+              <a:t>• Edge 1D Kalman Denoising:
+</a:t>
+            </a:r>
+            <a:r>
+              <a:rPr lang="en-US" sz="1100" dirty="0">
+                <a:solidFill>
+                  <a:srgbClr val="334155"/>
+                </a:solidFill>
+                <a:latin typeface="Calibri" pitchFamily="34" charset="0"/>
+                <a:ea typeface="Calibri" pitchFamily="34" charset="-122"/>
+                <a:cs typeface="Calibri" pitchFamily="34" charset="-120"/>
+              </a:rPr>
+              <a:t>  Filters raw pressure, temperature, and Coriolis vibration noise for crystal-clear anomaly detection.
+</a:t>
+            </a:r>
+            <a:r>
+              <a:rPr lang="en-US" sz="1150" b="1" dirty="0">
+                <a:solidFill>
+                  <a:srgbClr val="065F46"/>
+                </a:solidFill>
+                <a:latin typeface="Calibri" pitchFamily="34" charset="0"/>
+                <a:ea typeface="Calibri" pitchFamily="34" charset="-122"/>
+                <a:cs typeface="Calibri" pitchFamily="34" charset="-120"/>
+              </a:rPr>
+              <a:t>• Automated ASTM D1250 Net Oil Reconciliation:
+</a:t>
+            </a:r>
+            <a:r>
+              <a:rPr lang="en-US" sz="1100" dirty="0">
+                <a:solidFill>
+                  <a:srgbClr val="334155"/>
+                </a:solidFill>
+                <a:latin typeface="Calibri" pitchFamily="34" charset="0"/>
+                <a:ea typeface="Calibri" pitchFamily="34" charset="-122"/>
+                <a:cs typeface="Calibri" pitchFamily="34" charset="-120"/>
+              </a:rPr>
+              <a:t>  Continuously calculates Gross Extracted vs Net Dry Purified Oil, BS&amp;W water-cut %, and associated gas.
+</a:t>
+            </a:r>
+            <a:r>
+              <a:rPr lang="en-US" sz="1150" b="1" dirty="0">
+                <a:solidFill>
+                  <a:srgbClr val="065F46"/>
+                </a:solidFill>
+                <a:latin typeface="Calibri" pitchFamily="34" charset="0"/>
+                <a:ea typeface="Calibri" pitchFamily="34" charset="-122"/>
+                <a:cs typeface="Calibri" pitchFamily="34" charset="-120"/>
+              </a:rPr>
+              <a:t>• 180-Day Database &amp; Midnight Settlement:
+</a:t>
+            </a:r>
+            <a:r>
+              <a:rPr lang="en-US" sz="1100" dirty="0">
+                <a:solidFill>
+                  <a:srgbClr val="334155"/>
+                </a:solidFill>
+                <a:latin typeface="Calibri" pitchFamily="34" charset="0"/>
+                <a:ea typeface="Calibri" pitchFamily="34" charset="-122"/>
+                <a:cs typeface="Calibri" pitchFamily="34" charset="-120"/>
+              </a:rPr>
+              <a:t>  Local high-speed database with sub-millisecond binary search and automated 12:00 Midnight DGH regulatory audits.</a:t>
+            </a:r>
+            <a:endParaRPr lang="en-US" sz="1150" dirty="0"/>
+          </a:p>
+        </p:txBody>
+      </p:sp>
+      <p:pic>
+        <p:nvPicPr>
+          <p:cNvPr id="13" name="Picture 12">
+            <a:extLst>
+              <a:ext uri="{FF2B5EF4-FFF2-40B4-BE49-F238E27FC236}">
+                <a16:creationId xmlns:a16="http://schemas.microsoft.com/office/drawing/2014/main" id="{A85E4E3F-FBA7-9794-6BA5-C12B5F3EF400}"/>
+              </a:ext>
+            </a:extLst>
+          </p:cNvPr>
+          <p:cNvPicPr>
+            <a:picLocks noChangeAspect="1"/>
+          </p:cNvPicPr>
+          <p:nvPr/>
+        </p:nvPicPr>
+        <p:blipFill>
+          <a:blip r:embed="rId3">
+            <a:extLst>
+              <a:ext uri="{28A0092B-C50C-407E-A947-70E740481C1C}">
+                <a14:useLocalDpi xmlns:a14="http://schemas.microsoft.com/office/drawing/2010/main" val="0"/>
+              </a:ext>
+            </a:extLst>
+          </a:blip>
+          <a:stretch>
+            <a:fillRect/>
+          </a:stretch>
+        </p:blipFill>
+        <p:spPr>
+          <a:xfrm>
+            <a:off x="9780086" y="1500"/>
+            <a:ext cx="2249850" cy="1062337"/>
           </a:xfrm>
           <a:prstGeom prst="rect">
             <a:avLst/>
           </a:prstGeom>
-          <a:noFill/>
-          <a:ln/>
-        </p:spPr>
-        <p:txBody>
-          <a:bodyPr wrap="square" rtlCol="0" anchor="ctr"/>
-          <a:lstStyle/>
-          <a:p>
-            <a:pPr indent="0" marL="0">
-              <a:buNone/>
-            </a:pPr>
-            <a:r>
-              <a:rPr lang="en-US" sz="1500" b="1" dirty="0">
-                <a:solidFill>
-                  <a:srgbClr val="0F172A"/>
-                </a:solidFill>
-                <a:latin typeface="Calibri" pitchFamily="34" charset="0"/>
-                <a:ea typeface="Calibri" pitchFamily="34" charset="-122"/>
-                <a:cs typeface="Calibri" pitchFamily="34" charset="-120"/>
-              </a:rPr>
-              <a:t>Team ID </a:t>
-            </a:r>
-            <a:pPr indent="0" marL="0">
-              <a:buNone/>
-            </a:pPr>
-            <a:r>
-              <a:rPr lang="en-US" sz="1500" dirty="0">
-                <a:solidFill>
-                  <a:srgbClr val="1E293B"/>
-                </a:solidFill>
-                <a:latin typeface="Calibri" pitchFamily="34" charset="0"/>
-                <a:ea typeface="Calibri" pitchFamily="34" charset="-122"/>
-                <a:cs typeface="Calibri" pitchFamily="34" charset="-120"/>
-              </a:rPr>
-              <a:t>- [Enter Your Team ID]</a:t>
-            </a:r>
-            <a:endParaRPr lang="en-US" sz="1500" dirty="0"/>
-          </a:p>
-        </p:txBody>
-      </p:sp>
-      <p:sp>
-        <p:nvSpPr>
-          <p:cNvPr id="8" name="Text 6"/>
-          <p:cNvSpPr/>
-          <p:nvPr/>
-        </p:nvSpPr>
-        <p:spPr>
-          <a:xfrm>
-            <a:off x="731520" y="4800600"/>
-            <a:ext cx="10515600" cy="457200"/>
-          </a:xfrm>
-          <a:prstGeom prst="rect">
-            <a:avLst/>
-          </a:prstGeom>
-          <a:noFill/>
-          <a:ln/>
-        </p:spPr>
-        <p:txBody>
-          <a:bodyPr wrap="square" rtlCol="0" anchor="ctr"/>
-          <a:lstStyle/>
-          <a:p>
-            <a:pPr indent="0" marL="0">
-              <a:buNone/>
-            </a:pPr>
-            <a:r>
-              <a:rPr lang="en-US" sz="1500" b="1" dirty="0">
-                <a:solidFill>
-                  <a:srgbClr val="0F172A"/>
-                </a:solidFill>
-                <a:latin typeface="Calibri" pitchFamily="34" charset="0"/>
-                <a:ea typeface="Calibri" pitchFamily="34" charset="-122"/>
-                <a:cs typeface="Calibri" pitchFamily="34" charset="-120"/>
-              </a:rPr>
-              <a:t>Team Name </a:t>
-            </a:r>
-            <a:pPr indent="0" marL="0">
-              <a:buNone/>
-            </a:pPr>
-            <a:r>
-              <a:rPr lang="en-US" sz="1500" dirty="0">
-                <a:solidFill>
-                  <a:srgbClr val="1E293B"/>
-                </a:solidFill>
-                <a:latin typeface="Calibri" pitchFamily="34" charset="0"/>
-                <a:ea typeface="Calibri" pitchFamily="34" charset="-122"/>
-                <a:cs typeface="Calibri" pitchFamily="34" charset="-120"/>
-              </a:rPr>
-              <a:t>- [Enter Your Team Name]</a:t>
-            </a:r>
-            <a:endParaRPr lang="en-US" sz="1500" dirty="0"/>
-          </a:p>
-        </p:txBody>
-      </p:sp>
+        </p:spPr>
+      </p:pic>
     </p:spTree>
   </p:cSld>
   <p:clrMapOvr>
@@ -1685,14 +2172,15 @@
 </p:sld>
 </file>
 
-<file path=ppt/slides/slide2.xml><?xml version="1.0" encoding="utf-8"?>
+<file path=ppt/slides/slide3.xml><?xml version="1.0" encoding="utf-8"?>
 <p:sld xmlns:a="http://schemas.openxmlformats.org/drawingml/2006/main" xmlns:r="http://schemas.openxmlformats.org/officeDocument/2006/relationships" xmlns:p="http://schemas.openxmlformats.org/presentationml/2006/main">
-  <p:cSld name="Slide 2">
+  <p:cSld name="Slide 3">
     <p:bg>
       <p:bgPr>
         <a:solidFill>
           <a:srgbClr val="FFFFFF"/>
         </a:solidFill>
+        <a:effectLst/>
       </p:bgPr>
     </p:bg>
     <p:spTree>
@@ -1717,7 +2205,7 @@
         </p:nvSpPr>
         <p:spPr>
           <a:xfrm>
-            <a:off x="548640" y="320040"/>
+            <a:off x="548640" y="168812"/>
             <a:ext cx="3657600" cy="274320"/>
           </a:xfrm>
           <a:prstGeom prst="rect">
@@ -1730,7 +2218,7 @@
           <a:bodyPr wrap="square" rtlCol="0" anchor="ctr"/>
           <a:lstStyle/>
           <a:p>
-            <a:pPr indent="0" marL="0">
+            <a:pPr marL="0" indent="0">
               <a:buNone/>
             </a:pPr>
             <a:r>
@@ -1756,7 +2244,7 @@
         </p:nvSpPr>
         <p:spPr>
           <a:xfrm>
-            <a:off x="548640" y="640080"/>
+            <a:off x="548640" y="516284"/>
             <a:ext cx="9144000" cy="548640"/>
           </a:xfrm>
           <a:prstGeom prst="rect">
@@ -1769,7 +2257,7 @@
           <a:bodyPr wrap="square" rtlCol="0" anchor="ctr"/>
           <a:lstStyle/>
           <a:p>
-            <a:pPr indent="0" marL="0">
+            <a:pPr marL="0" indent="0">
               <a:buNone/>
             </a:pPr>
             <a:r>
@@ -1781,7 +2269,7 @@
                 <a:ea typeface="Arial Black" pitchFamily="34" charset="-122"/>
                 <a:cs typeface="Arial Black" pitchFamily="34" charset="-120"/>
               </a:rPr>
-              <a:t>PROPOSED SOLUTION</a:t>
+              <a:t>TECHNICAL APPROACH: SYSTEM WORKFLOW &amp; ARCHITECTURE</a:t>
             </a:r>
             <a:endParaRPr lang="en-US" sz="2400" dirty="0"/>
           </a:p>
@@ -1808,7 +2296,7 @@
           <a:bodyPr wrap="square" rtlCol="0" anchor="ctr"/>
           <a:lstStyle/>
           <a:p>
-            <a:pPr indent="0" marL="0">
+            <a:pPr marL="0" indent="0">
               <a:buNone/>
             </a:pPr>
             <a:r>
@@ -1820,7 +2308,7 @@
                 <a:ea typeface="Arial" pitchFamily="34" charset="-122"/>
                 <a:cs typeface="Arial" pitchFamily="34" charset="-120"/>
               </a:rPr>
-              <a:t>2 @SIH Idea submission-Template</a:t>
+              <a:t>3 @SIH Idea submission-Template</a:t>
             </a:r>
             <a:endParaRPr lang="en-US" sz="900" dirty="0"/>
           </a:p>
@@ -1847,7 +2335,7 @@
           <a:bodyPr wrap="square" rtlCol="0" anchor="ctr"/>
           <a:lstStyle/>
           <a:p>
-            <a:pPr algn="r" indent="0" marL="0">
+            <a:pPr marL="0" indent="0" algn="r">
               <a:buNone/>
             </a:pPr>
             <a:r>
@@ -1865,632 +2353,24 @@
           </a:p>
         </p:txBody>
       </p:sp>
-      <p:sp>
-        <p:nvSpPr>
-          <p:cNvPr id="6" name="Shape 4"/>
-          <p:cNvSpPr/>
-          <p:nvPr/>
-        </p:nvSpPr>
-        <p:spPr>
-          <a:xfrm>
-            <a:off x="548640" y="1280160"/>
-            <a:ext cx="5303520" cy="4846320"/>
-          </a:xfrm>
-          <a:prstGeom prst="roundRect">
-            <a:avLst>
-              <a:gd name="adj" fmla="val 1887"/>
-            </a:avLst>
-          </a:prstGeom>
-          <a:solidFill>
-            <a:srgbClr val="F8FAFC"/>
-          </a:solidFill>
-          <a:ln w="12700">
-            <a:solidFill>
-              <a:srgbClr val="E2E8F0"/>
-            </a:solidFill>
-            <a:prstDash val="solid"/>
-          </a:ln>
-        </p:spPr>
-      </p:sp>
-      <p:sp>
-        <p:nvSpPr>
-          <p:cNvPr id="7" name="Text 5"/>
-          <p:cNvSpPr/>
-          <p:nvPr/>
-        </p:nvSpPr>
-        <p:spPr>
-          <a:xfrm>
-            <a:off x="731520" y="1417320"/>
-            <a:ext cx="4937760" cy="320040"/>
-          </a:xfrm>
-          <a:prstGeom prst="rect">
-            <a:avLst/>
-          </a:prstGeom>
-          <a:noFill/>
-          <a:ln/>
-        </p:spPr>
-        <p:txBody>
-          <a:bodyPr wrap="square" rtlCol="0" anchor="ctr"/>
-          <a:lstStyle/>
-          <a:p>
-            <a:pPr indent="0" marL="0">
-              <a:buNone/>
-            </a:pPr>
-            <a:r>
-              <a:rPr lang="en-US" sz="1300" b="1" dirty="0">
-                <a:solidFill>
-                  <a:srgbClr val="991B1B"/>
-                </a:solidFill>
-                <a:latin typeface="Arial" pitchFamily="34" charset="0"/>
-                <a:ea typeface="Arial" pitchFamily="34" charset="-122"/>
-                <a:cs typeface="Arial" pitchFamily="34" charset="-120"/>
-              </a:rPr>
-              <a:t>PROBLEM STATEMENT &amp; CHALLENGES</a:t>
-            </a:r>
-            <a:endParaRPr lang="en-US" sz="1300" dirty="0"/>
-          </a:p>
-        </p:txBody>
-      </p:sp>
-      <p:sp>
-        <p:nvSpPr>
-          <p:cNvPr id="8" name="Text 6"/>
-          <p:cNvSpPr/>
-          <p:nvPr/>
-        </p:nvSpPr>
-        <p:spPr>
-          <a:xfrm>
-            <a:off x="731520" y="1828800"/>
-            <a:ext cx="4937760" cy="4114800"/>
-          </a:xfrm>
-          <a:prstGeom prst="rect">
-            <a:avLst/>
-          </a:prstGeom>
-          <a:noFill/>
-          <a:ln/>
-        </p:spPr>
-        <p:txBody>
-          <a:bodyPr wrap="square" rtlCol="0" anchor="ctr"/>
-          <a:lstStyle/>
-          <a:p>
-            <a:pPr indent="0" marL="0">
-              <a:buNone/>
-            </a:pPr>
-            <a:r>
-              <a:rPr lang="en-US" sz="1150" b="1" dirty="0">
-                <a:solidFill>
-                  <a:srgbClr val="0F172A"/>
-                </a:solidFill>
-                <a:latin typeface="Calibri" pitchFamily="34" charset="0"/>
-                <a:ea typeface="Calibri" pitchFamily="34" charset="-122"/>
-                <a:cs typeface="Calibri" pitchFamily="34" charset="-120"/>
-              </a:rPr>
-              <a:t>• Blind Subsurface Operations:
-</a:t>
-            </a:r>
-            <a:pPr indent="0" marL="0">
-              <a:buNone/>
-            </a:pPr>
-            <a:r>
-              <a:rPr lang="en-US" sz="1100" dirty="0">
-                <a:solidFill>
-                  <a:srgbClr val="334155"/>
-                </a:solidFill>
-                <a:latin typeface="Calibri" pitchFamily="34" charset="0"/>
-                <a:ea typeface="Calibri" pitchFamily="34" charset="-122"/>
-                <a:cs typeface="Calibri" pitchFamily="34" charset="-120"/>
-              </a:rPr>
-              <a:t>  Zero real-time visibility into deepwater wellhead dynamics, downhole PDC drill torque, and multi-phase flow lines.
-</a:t>
-            </a:r>
-            <a:pPr indent="0" marL="0">
-              <a:buNone/>
-            </a:pPr>
-            <a:r>
-              <a:rPr lang="en-US" sz="1150" b="1" dirty="0">
-                <a:solidFill>
-                  <a:srgbClr val="0F172A"/>
-                </a:solidFill>
-                <a:latin typeface="Calibri" pitchFamily="34" charset="0"/>
-                <a:ea typeface="Calibri" pitchFamily="34" charset="-122"/>
-                <a:cs typeface="Calibri" pitchFamily="34" charset="-120"/>
-              </a:rPr>
-              <a:t>• Costly Unscheduled Downtime:
-</a:t>
-            </a:r>
-            <a:pPr indent="0" marL="0">
-              <a:buNone/>
-            </a:pPr>
-            <a:r>
-              <a:rPr lang="en-US" sz="1100" dirty="0">
-                <a:solidFill>
-                  <a:srgbClr val="334155"/>
-                </a:solidFill>
-                <a:latin typeface="Calibri" pitchFamily="34" charset="0"/>
-                <a:ea typeface="Calibri" pitchFamily="34" charset="-122"/>
-                <a:cs typeface="Calibri" pitchFamily="34" charset="-120"/>
-              </a:rPr>
-              <a:t>  Reactive maintenance leads to catastrophic pump failures, stuck pipe incidents, and ₹25L+ losses per event.
-</a:t>
-            </a:r>
-            <a:pPr indent="0" marL="0">
-              <a:buNone/>
-            </a:pPr>
-            <a:r>
-              <a:rPr lang="en-US" sz="1150" b="1" dirty="0">
-                <a:solidFill>
-                  <a:srgbClr val="0F172A"/>
-                </a:solidFill>
-                <a:latin typeface="Calibri" pitchFamily="34" charset="0"/>
-                <a:ea typeface="Calibri" pitchFamily="34" charset="-122"/>
-                <a:cs typeface="Calibri" pitchFamily="34" charset="-120"/>
-              </a:rPr>
-              <a:t>• Undetected Water/Gas Breakthroughs:
-</a:t>
-            </a:r>
-            <a:pPr indent="0" marL="0">
-              <a:buNone/>
-            </a:pPr>
-            <a:r>
-              <a:rPr lang="en-US" sz="1100" dirty="0">
-                <a:solidFill>
-                  <a:srgbClr val="334155"/>
-                </a:solidFill>
-                <a:latin typeface="Calibri" pitchFamily="34" charset="0"/>
-                <a:ea typeface="Calibri" pitchFamily="34" charset="-122"/>
-                <a:cs typeface="Calibri" pitchFamily="34" charset="-120"/>
-              </a:rPr>
-              <a:t>  Emulsion surges and hydrate plugs choke subsea flowlines without early warning or ASTM D1250 net oil purification.
-</a:t>
-            </a:r>
-            <a:pPr indent="0" marL="0">
-              <a:buNone/>
-            </a:pPr>
-            <a:r>
-              <a:rPr lang="en-US" sz="1150" b="1" dirty="0">
-                <a:solidFill>
-                  <a:srgbClr val="0F172A"/>
-                </a:solidFill>
-                <a:latin typeface="Calibri" pitchFamily="34" charset="0"/>
-                <a:ea typeface="Calibri" pitchFamily="34" charset="-122"/>
-                <a:cs typeface="Calibri" pitchFamily="34" charset="-120"/>
-              </a:rPr>
-              <a:t>• Fragmented Industrial Data:
-</a:t>
-            </a:r>
-            <a:pPr indent="0" marL="0">
-              <a:buNone/>
-            </a:pPr>
-            <a:r>
-              <a:rPr lang="en-US" sz="1100" dirty="0">
-                <a:solidFill>
-                  <a:srgbClr val="334155"/>
-                </a:solidFill>
-                <a:latin typeface="Calibri" pitchFamily="34" charset="0"/>
-                <a:ea typeface="Calibri" pitchFamily="34" charset="-122"/>
-                <a:cs typeface="Calibri" pitchFamily="34" charset="-120"/>
-              </a:rPr>
-              <a:t>  Telemetry is siloed across SCADA systems with no 3D spatial twin or automated midnight settlement compliance.</a:t>
-            </a:r>
-            <a:endParaRPr lang="en-US" sz="1150" dirty="0"/>
-          </a:p>
-        </p:txBody>
-      </p:sp>
-      <p:sp>
-        <p:nvSpPr>
-          <p:cNvPr id="9" name="Shape 7"/>
-          <p:cNvSpPr/>
-          <p:nvPr/>
-        </p:nvSpPr>
-        <p:spPr>
-          <a:xfrm>
-            <a:off x="6035040" y="1280160"/>
-            <a:ext cx="5577840" cy="4846320"/>
-          </a:xfrm>
-          <a:prstGeom prst="roundRect">
-            <a:avLst>
-              <a:gd name="adj" fmla="val 1887"/>
-            </a:avLst>
-          </a:prstGeom>
-          <a:solidFill>
-            <a:srgbClr val="F0FDF4"/>
-          </a:solidFill>
-          <a:ln w="12700">
-            <a:solidFill>
-              <a:srgbClr val="BBF7D0"/>
-            </a:solidFill>
-            <a:prstDash val="solid"/>
-          </a:ln>
-        </p:spPr>
-      </p:sp>
-      <p:sp>
-        <p:nvSpPr>
-          <p:cNvPr id="10" name="Text 8"/>
-          <p:cNvSpPr/>
-          <p:nvPr/>
-        </p:nvSpPr>
-        <p:spPr>
-          <a:xfrm>
-            <a:off x="6217920" y="1417320"/>
-            <a:ext cx="5212080" cy="320040"/>
-          </a:xfrm>
-          <a:prstGeom prst="rect">
-            <a:avLst/>
-          </a:prstGeom>
-          <a:noFill/>
-          <a:ln/>
-        </p:spPr>
-        <p:txBody>
-          <a:bodyPr wrap="square" rtlCol="0" anchor="ctr"/>
-          <a:lstStyle/>
-          <a:p>
-            <a:pPr indent="0" marL="0">
-              <a:buNone/>
-            </a:pPr>
-            <a:r>
-              <a:rPr lang="en-US" sz="1300" b="1" dirty="0">
-                <a:solidFill>
-                  <a:srgbClr val="065F46"/>
-                </a:solidFill>
-                <a:latin typeface="Arial" pitchFamily="34" charset="0"/>
-                <a:ea typeface="Arial" pitchFamily="34" charset="-122"/>
-                <a:cs typeface="Arial" pitchFamily="34" charset="-120"/>
-              </a:rPr>
-              <a:t>PROPOSED SOLUTION (VARUNA-AI)</a:t>
-            </a:r>
-            <a:endParaRPr lang="en-US" sz="1300" dirty="0"/>
-          </a:p>
-        </p:txBody>
-      </p:sp>
-      <p:sp>
-        <p:nvSpPr>
-          <p:cNvPr id="11" name="Text 9"/>
-          <p:cNvSpPr/>
-          <p:nvPr/>
-        </p:nvSpPr>
-        <p:spPr>
-          <a:xfrm>
-            <a:off x="6217920" y="1828800"/>
-            <a:ext cx="5212080" cy="4114800"/>
-          </a:xfrm>
-          <a:prstGeom prst="rect">
-            <a:avLst/>
-          </a:prstGeom>
-          <a:noFill/>
-          <a:ln/>
-        </p:spPr>
-        <p:txBody>
-          <a:bodyPr wrap="square" rtlCol="0" anchor="ctr"/>
-          <a:lstStyle/>
-          <a:p>
-            <a:pPr indent="0" marL="0">
-              <a:buNone/>
-            </a:pPr>
-            <a:r>
-              <a:rPr lang="en-US" sz="1150" b="1" dirty="0">
-                <a:solidFill>
-                  <a:srgbClr val="065F46"/>
-                </a:solidFill>
-                <a:latin typeface="Calibri" pitchFamily="34" charset="0"/>
-                <a:ea typeface="Calibri" pitchFamily="34" charset="-122"/>
-                <a:cs typeface="Calibri" pitchFamily="34" charset="-120"/>
-              </a:rPr>
-              <a:t>• 50.0 Hz Physics-Informed Cyber-Twin:
-</a:t>
-            </a:r>
-            <a:pPr indent="0" marL="0">
-              <a:buNone/>
-            </a:pPr>
-            <a:r>
-              <a:rPr lang="en-US" sz="1100" dirty="0">
-                <a:solidFill>
-                  <a:srgbClr val="334155"/>
-                </a:solidFill>
-                <a:latin typeface="Calibri" pitchFamily="34" charset="0"/>
-                <a:ea typeface="Calibri" pitchFamily="34" charset="-122"/>
-                <a:cs typeface="Calibri" pitchFamily="34" charset="-120"/>
-              </a:rPr>
-              <a:t>  Real-time subsea-to-topside 3D visualization in WebGL/Three.js with 20ms ultra-fast sensor ingestion.
-</a:t>
-            </a:r>
-            <a:pPr indent="0" marL="0">
-              <a:buNone/>
-            </a:pPr>
-            <a:r>
-              <a:rPr lang="en-US" sz="1150" b="1" dirty="0">
-                <a:solidFill>
-                  <a:srgbClr val="065F46"/>
-                </a:solidFill>
-                <a:latin typeface="Calibri" pitchFamily="34" charset="0"/>
-                <a:ea typeface="Calibri" pitchFamily="34" charset="-122"/>
-                <a:cs typeface="Calibri" pitchFamily="34" charset="-120"/>
-              </a:rPr>
-              <a:t>• Edge 1D Kalman Denoising:
-</a:t>
-            </a:r>
-            <a:pPr indent="0" marL="0">
-              <a:buNone/>
-            </a:pPr>
-            <a:r>
-              <a:rPr lang="en-US" sz="1100" dirty="0">
-                <a:solidFill>
-                  <a:srgbClr val="334155"/>
-                </a:solidFill>
-                <a:latin typeface="Calibri" pitchFamily="34" charset="0"/>
-                <a:ea typeface="Calibri" pitchFamily="34" charset="-122"/>
-                <a:cs typeface="Calibri" pitchFamily="34" charset="-120"/>
-              </a:rPr>
-              <a:t>  Filters raw pressure, temperature, and Coriolis vibration noise for crystal-clear anomaly detection.
-</a:t>
-            </a:r>
-            <a:pPr indent="0" marL="0">
-              <a:buNone/>
-            </a:pPr>
-            <a:r>
-              <a:rPr lang="en-US" sz="1150" b="1" dirty="0">
-                <a:solidFill>
-                  <a:srgbClr val="065F46"/>
-                </a:solidFill>
-                <a:latin typeface="Calibri" pitchFamily="34" charset="0"/>
-                <a:ea typeface="Calibri" pitchFamily="34" charset="-122"/>
-                <a:cs typeface="Calibri" pitchFamily="34" charset="-120"/>
-              </a:rPr>
-              <a:t>• Automated ASTM D1250 Net Oil Reconciliation:
-</a:t>
-            </a:r>
-            <a:pPr indent="0" marL="0">
-              <a:buNone/>
-            </a:pPr>
-            <a:r>
-              <a:rPr lang="en-US" sz="1100" dirty="0">
-                <a:solidFill>
-                  <a:srgbClr val="334155"/>
-                </a:solidFill>
-                <a:latin typeface="Calibri" pitchFamily="34" charset="0"/>
-                <a:ea typeface="Calibri" pitchFamily="34" charset="-122"/>
-                <a:cs typeface="Calibri" pitchFamily="34" charset="-120"/>
-              </a:rPr>
-              <a:t>  Continuously calculates Gross Extracted vs Net Dry Purified Oil, BS&amp;W water-cut %, and associated gas.
-</a:t>
-            </a:r>
-            <a:pPr indent="0" marL="0">
-              <a:buNone/>
-            </a:pPr>
-            <a:r>
-              <a:rPr lang="en-US" sz="1150" b="1" dirty="0">
-                <a:solidFill>
-                  <a:srgbClr val="065F46"/>
-                </a:solidFill>
-                <a:latin typeface="Calibri" pitchFamily="34" charset="0"/>
-                <a:ea typeface="Calibri" pitchFamily="34" charset="-122"/>
-                <a:cs typeface="Calibri" pitchFamily="34" charset="-120"/>
-              </a:rPr>
-              <a:t>• 180-Day Database &amp; Midnight Settlement:
-</a:t>
-            </a:r>
-            <a:pPr indent="0" marL="0">
-              <a:buNone/>
-            </a:pPr>
-            <a:r>
-              <a:rPr lang="en-US" sz="1100" dirty="0">
-                <a:solidFill>
-                  <a:srgbClr val="334155"/>
-                </a:solidFill>
-                <a:latin typeface="Calibri" pitchFamily="34" charset="0"/>
-                <a:ea typeface="Calibri" pitchFamily="34" charset="-122"/>
-                <a:cs typeface="Calibri" pitchFamily="34" charset="-120"/>
-              </a:rPr>
-              <a:t>  Local high-speed database with sub-millisecond binary search and automated 12:00 Midnight DGH regulatory audits.</a:t>
-            </a:r>
-            <a:endParaRPr lang="en-US" sz="1150" dirty="0"/>
-          </a:p>
-        </p:txBody>
-      </p:sp>
-    </p:spTree>
-  </p:cSld>
-  <p:clrMapOvr>
-    <a:masterClrMapping/>
-  </p:clrMapOvr>
-</p:sld>
-</file>
-
-<file path=ppt/slides/slide3.xml><?xml version="1.0" encoding="utf-8"?>
-<p:sld xmlns:a="http://schemas.openxmlformats.org/drawingml/2006/main" xmlns:r="http://schemas.openxmlformats.org/officeDocument/2006/relationships" xmlns:p="http://schemas.openxmlformats.org/presentationml/2006/main">
-  <p:cSld name="Slide 3">
-    <p:bg>
-      <p:bgPr>
-        <a:solidFill>
-          <a:srgbClr val="FFFFFF"/>
-        </a:solidFill>
-      </p:bgPr>
-    </p:bg>
-    <p:spTree>
-      <p:nvGrpSpPr>
-        <p:cNvPr id="1" name=""/>
-        <p:cNvGrpSpPr/>
-        <p:nvPr/>
-      </p:nvGrpSpPr>
-      <p:grpSpPr>
-        <a:xfrm>
-          <a:off x="0" y="0"/>
-          <a:ext cx="0" cy="0"/>
-          <a:chOff x="0" y="0"/>
-          <a:chExt cx="0" cy="0"/>
-        </a:xfrm>
-      </p:grpSpPr>
-      <p:sp>
-        <p:nvSpPr>
-          <p:cNvPr id="2" name="Text 0"/>
-          <p:cNvSpPr/>
-          <p:nvPr/>
-        </p:nvSpPr>
-        <p:spPr>
-          <a:xfrm>
-            <a:off x="548640" y="320040"/>
-            <a:ext cx="3657600" cy="274320"/>
-          </a:xfrm>
-          <a:prstGeom prst="rect">
-            <a:avLst/>
-          </a:prstGeom>
-          <a:noFill/>
-          <a:ln/>
-        </p:spPr>
-        <p:txBody>
-          <a:bodyPr wrap="square" rtlCol="0" anchor="ctr"/>
-          <a:lstStyle/>
-          <a:p>
-            <a:pPr indent="0" marL="0">
-              <a:buNone/>
-            </a:pPr>
-            <a:r>
-              <a:rPr lang="en-US" sz="1100" b="1" dirty="0">
-                <a:solidFill>
-                  <a:srgbClr val="D97706"/>
-                </a:solidFill>
-                <a:latin typeface="Arial" pitchFamily="34" charset="0"/>
-                <a:ea typeface="Arial" pitchFamily="34" charset="-122"/>
-                <a:cs typeface="Arial" pitchFamily="34" charset="-120"/>
-              </a:rPr>
-              <a:t>Smart India Hackathon 2026</a:t>
-            </a:r>
-            <a:endParaRPr lang="en-US" sz="1100" dirty="0"/>
-          </a:p>
-        </p:txBody>
-      </p:sp>
-      <p:sp>
-        <p:nvSpPr>
-          <p:cNvPr id="3" name="Text 1"/>
-          <p:cNvSpPr/>
-          <p:nvPr/>
-        </p:nvSpPr>
-        <p:spPr>
-          <a:xfrm>
-            <a:off x="548640" y="640080"/>
-            <a:ext cx="9144000" cy="548640"/>
-          </a:xfrm>
-          <a:prstGeom prst="rect">
-            <a:avLst/>
-          </a:prstGeom>
-          <a:noFill/>
-          <a:ln/>
-        </p:spPr>
-        <p:txBody>
-          <a:bodyPr wrap="square" rtlCol="0" anchor="ctr"/>
-          <a:lstStyle/>
-          <a:p>
-            <a:pPr indent="0" marL="0">
-              <a:buNone/>
-            </a:pPr>
-            <a:r>
-              <a:rPr lang="en-US" sz="2400" b="1" dirty="0">
-                <a:solidFill>
-                  <a:srgbClr val="1E3A8A"/>
-                </a:solidFill>
-                <a:latin typeface="Arial Black" pitchFamily="34" charset="0"/>
-                <a:ea typeface="Arial Black" pitchFamily="34" charset="-122"/>
-                <a:cs typeface="Arial Black" pitchFamily="34" charset="-120"/>
-              </a:rPr>
-              <a:t>TECHNICAL APPROACH: SYSTEM WORKFLOW &amp; ARCHITECTURE</a:t>
-            </a:r>
-            <a:endParaRPr lang="en-US" sz="2400" dirty="0"/>
-          </a:p>
-        </p:txBody>
-      </p:sp>
-      <p:sp>
-        <p:nvSpPr>
-          <p:cNvPr id="4" name="Text 2"/>
-          <p:cNvSpPr/>
-          <p:nvPr/>
-        </p:nvSpPr>
-        <p:spPr>
-          <a:xfrm>
-            <a:off x="548640" y="6309360"/>
-            <a:ext cx="3657600" cy="274320"/>
-          </a:xfrm>
-          <a:prstGeom prst="rect">
-            <a:avLst/>
-          </a:prstGeom>
-          <a:noFill/>
-          <a:ln/>
-        </p:spPr>
-        <p:txBody>
-          <a:bodyPr wrap="square" rtlCol="0" anchor="ctr"/>
-          <a:lstStyle/>
-          <a:p>
-            <a:pPr indent="0" marL="0">
-              <a:buNone/>
-            </a:pPr>
-            <a:r>
-              <a:rPr lang="en-US" sz="900" dirty="0">
-                <a:solidFill>
-                  <a:srgbClr val="64748B"/>
-                </a:solidFill>
-                <a:latin typeface="Arial" pitchFamily="34" charset="0"/>
-                <a:ea typeface="Arial" pitchFamily="34" charset="-122"/>
-                <a:cs typeface="Arial" pitchFamily="34" charset="-120"/>
-              </a:rPr>
-              <a:t>3 @SIH Idea submission-Template</a:t>
-            </a:r>
-            <a:endParaRPr lang="en-US" sz="900" dirty="0"/>
-          </a:p>
-        </p:txBody>
-      </p:sp>
-      <p:sp>
-        <p:nvSpPr>
-          <p:cNvPr id="5" name="Text 3"/>
-          <p:cNvSpPr/>
-          <p:nvPr/>
-        </p:nvSpPr>
-        <p:spPr>
-          <a:xfrm>
-            <a:off x="9144000" y="6309360"/>
-            <a:ext cx="2468880" cy="274320"/>
-          </a:xfrm>
-          <a:prstGeom prst="rect">
-            <a:avLst/>
-          </a:prstGeom>
-          <a:noFill/>
-          <a:ln/>
-        </p:spPr>
-        <p:txBody>
-          <a:bodyPr wrap="square" rtlCol="0" anchor="ctr"/>
-          <a:lstStyle/>
-          <a:p>
-            <a:pPr algn="r" indent="0" marL="0">
-              <a:buNone/>
-            </a:pPr>
-            <a:r>
-              <a:rPr lang="en-US" sz="900" dirty="0">
-                <a:solidFill>
-                  <a:srgbClr val="64748B"/>
-                </a:solidFill>
-                <a:latin typeface="Arial" pitchFamily="34" charset="0"/>
-                <a:ea typeface="Arial" pitchFamily="34" charset="-122"/>
-                <a:cs typeface="Arial" pitchFamily="34" charset="-120"/>
-              </a:rPr>
-              <a:t>[Enter Your Team Name]</a:t>
-            </a:r>
-            <a:endParaRPr lang="en-US" sz="900" dirty="0"/>
-          </a:p>
-        </p:txBody>
-      </p:sp>
       <p:pic>
         <p:nvPicPr>
-          <p:cNvPr id="6" name="Image 0" descr="E:\Digital Twin\public\presentation\workflow_diagram_stencil.jpg">    </p:cNvPr>
+          <p:cNvPr id="6" name="Image 0" descr="E:\Digital Twin\public\presentation\workflow_diagram_stencil.jpg"/>
           <p:cNvPicPr>
             <a:picLocks noChangeAspect="1"/>
           </p:cNvPicPr>
           <p:nvPr/>
         </p:nvPicPr>
         <p:blipFill>
-          <a:blip r:embed="rId1"/>
+          <a:blip r:embed="rId3"/>
           <a:stretch>
             <a:fillRect/>
           </a:stretch>
         </p:blipFill>
         <p:spPr>
           <a:xfrm>
-            <a:off x="548640" y="1188720"/>
-            <a:ext cx="11091672" cy="3246120"/>
+            <a:off x="548640" y="1064924"/>
+            <a:ext cx="11091672" cy="3369916"/>
           </a:xfrm>
           <a:prstGeom prst="rect">
             <a:avLst/>
@@ -2545,7 +2425,7 @@
           <a:bodyPr wrap="square" rtlCol="0" anchor="ctr"/>
           <a:lstStyle/>
           <a:p>
-            <a:pPr indent="0" marL="0">
+            <a:pPr marL="0" indent="0">
               <a:buNone/>
             </a:pPr>
             <a:r>
@@ -2584,7 +2464,7 @@
           <a:bodyPr wrap="square" rtlCol="0" anchor="ctr"/>
           <a:lstStyle/>
           <a:p>
-            <a:pPr indent="0" marL="0">
+            <a:pPr marL="0" indent="0">
               <a:buNone/>
             </a:pPr>
             <a:r>
@@ -2598,9 +2478,6 @@
               </a:rPr>
               <a:t>• Stage 1 (Edge SCADA): </a:t>
             </a:r>
-            <a:pPr indent="0" marL="0">
-              <a:buNone/>
-            </a:pPr>
             <a:r>
               <a:rPr lang="en-US" sz="850" dirty="0">
                 <a:solidFill>
@@ -2613,9 +2490,6 @@
               <a:t>Modbus RTU/TCP, OPC-UA, WITSML, Serial USB WebGateway (50Hz / 20ms).
 </a:t>
             </a:r>
-            <a:pPr indent="0" marL="0">
-              <a:buNone/>
-            </a:pPr>
             <a:r>
               <a:rPr lang="en-US" sz="850" b="1" dirty="0">
                 <a:solidFill>
@@ -2627,9 +2501,6 @@
               </a:rPr>
               <a:t>• Stage 2 (Denoising): </a:t>
             </a:r>
-            <a:pPr indent="0" marL="0">
-              <a:buNone/>
-            </a:pPr>
             <a:r>
               <a:rPr lang="en-US" sz="850" dirty="0">
                 <a:solidFill>
@@ -2642,9 +2513,6 @@
               <a:t>Discrete 1D Kalman recursive state estimator + 180-day local buffer ledger (&lt;0.1ms query).
 </a:t>
             </a:r>
-            <a:pPr indent="0" marL="0">
-              <a:buNone/>
-            </a:pPr>
             <a:r>
               <a:rPr lang="en-US" sz="850" b="1" dirty="0">
                 <a:solidFill>
@@ -2656,9 +2524,6 @@
               </a:rPr>
               <a:t>• Stage 3 (Physics &amp; AI): </a:t>
             </a:r>
-            <a:pPr indent="0" marL="0">
-              <a:buNone/>
-            </a:pPr>
             <a:r>
               <a:rPr lang="en-US" sz="850" dirty="0">
                 <a:solidFill>
@@ -2671,9 +2536,6 @@
               <a:t>Darcy-Weisbach multiphase hydraulics, ASTM D1250 / API MPMS 11.1 net oil solver, XGBoost AI.
 </a:t>
             </a:r>
-            <a:pPr indent="0" marL="0">
-              <a:buNone/>
-            </a:pPr>
             <a:r>
               <a:rPr lang="en-US" sz="850" b="1" dirty="0">
                 <a:solidFill>
@@ -2685,9 +2547,6 @@
               </a:rPr>
               <a:t>• Stage 4 &amp; 5 (Twin &amp; Audit): </a:t>
             </a:r>
-            <a:pPr indent="0" marL="0">
-              <a:buNone/>
-            </a:pPr>
             <a:r>
               <a:rPr lang="en-US" sz="850" dirty="0">
                 <a:solidFill>
@@ -2705,14 +2564,14 @@
       </p:sp>
       <p:pic>
         <p:nvPicPr>
-          <p:cNvPr id="10" name="Image 1" descr="E:\Digital Twin\public\presentation\rig_diorama_colored_1789147250513.jpg">    </p:cNvPr>
+          <p:cNvPr id="10" name="Image 1" descr="E:\Digital Twin\public\presentation\rig_diorama_colored_1789147250513.jpg"/>
           <p:cNvPicPr>
             <a:picLocks noChangeAspect="1"/>
           </p:cNvPicPr>
           <p:nvPr/>
         </p:nvPicPr>
         <p:blipFill>
-          <a:blip r:embed="rId2"/>
+          <a:blip r:embed="rId4"/>
           <a:stretch>
             <a:fillRect/>
           </a:stretch>
@@ -2729,14 +2588,14 @@
       </p:pic>
       <p:pic>
         <p:nvPicPr>
-          <p:cNvPr id="11" name="Image 2" descr="E:\Digital Twin\public\presentation\hologram_digital_twin_1789148609789.jpg">    </p:cNvPr>
+          <p:cNvPr id="11" name="Image 2" descr="E:\Digital Twin\public\presentation\hologram_digital_twin_1789148609789.jpg"/>
           <p:cNvPicPr>
             <a:picLocks noChangeAspect="1"/>
           </p:cNvPicPr>
           <p:nvPr/>
         </p:nvPicPr>
         <p:blipFill>
-          <a:blip r:embed="rId3"/>
+          <a:blip r:embed="rId5"/>
           <a:stretch>
             <a:fillRect/>
           </a:stretch>
@@ -2745,6 +2604,42 @@
           <a:xfrm>
             <a:off x="9994392" y="4526280"/>
             <a:ext cx="1645920" cy="1691640"/>
+          </a:xfrm>
+          <a:prstGeom prst="rect">
+            <a:avLst/>
+          </a:prstGeom>
+        </p:spPr>
+      </p:pic>
+      <p:pic>
+        <p:nvPicPr>
+          <p:cNvPr id="13" name="Picture 12">
+            <a:extLst>
+              <a:ext uri="{FF2B5EF4-FFF2-40B4-BE49-F238E27FC236}">
+                <a16:creationId xmlns:a16="http://schemas.microsoft.com/office/drawing/2014/main" id="{2E929DDB-97CE-CC19-ACC0-A00D8DD5842D}"/>
+              </a:ext>
+            </a:extLst>
+          </p:cNvPr>
+          <p:cNvPicPr>
+            <a:picLocks noChangeAspect="1"/>
+          </p:cNvPicPr>
+          <p:nvPr/>
+        </p:nvPicPr>
+        <p:blipFill>
+          <a:blip r:embed="rId6">
+            <a:extLst>
+              <a:ext uri="{28A0092B-C50C-407E-A947-70E740481C1C}">
+                <a14:useLocalDpi xmlns:a14="http://schemas.microsoft.com/office/drawing/2010/main" val="0"/>
+              </a:ext>
+            </a:extLst>
+          </a:blip>
+          <a:stretch>
+            <a:fillRect/>
+          </a:stretch>
+        </p:blipFill>
+        <p:spPr>
+          <a:xfrm>
+            <a:off x="9780086" y="1500"/>
+            <a:ext cx="2249850" cy="1062337"/>
           </a:xfrm>
           <a:prstGeom prst="rect">
             <a:avLst/>
@@ -2767,6 +2662,7 @@
         <a:solidFill>
           <a:srgbClr val="FFFFFF"/>
         </a:solidFill>
+        <a:effectLst/>
       </p:bgPr>
     </p:bg>
     <p:spTree>
@@ -2804,7 +2700,7 @@
           <a:bodyPr wrap="square" rtlCol="0" anchor="ctr"/>
           <a:lstStyle/>
           <a:p>
-            <a:pPr indent="0" marL="0">
+            <a:pPr marL="0" indent="0">
               <a:buNone/>
             </a:pPr>
             <a:r>
@@ -2843,7 +2739,7 @@
           <a:bodyPr wrap="square" rtlCol="0" anchor="ctr"/>
           <a:lstStyle/>
           <a:p>
-            <a:pPr indent="0" marL="0">
+            <a:pPr marL="0" indent="0">
               <a:buNone/>
             </a:pPr>
             <a:r>
@@ -2882,7 +2778,7 @@
           <a:bodyPr wrap="square" rtlCol="0" anchor="ctr"/>
           <a:lstStyle/>
           <a:p>
-            <a:pPr indent="0" marL="0">
+            <a:pPr marL="0" indent="0">
               <a:buNone/>
             </a:pPr>
             <a:r>
@@ -2921,7 +2817,7 @@
           <a:bodyPr wrap="square" rtlCol="0" anchor="ctr"/>
           <a:lstStyle/>
           <a:p>
-            <a:pPr algn="r" indent="0" marL="0">
+            <a:pPr marL="0" indent="0" algn="r">
               <a:buNone/>
             </a:pPr>
             <a:r>
@@ -2960,7 +2856,7 @@
           <a:bodyPr wrap="square" rtlCol="0" anchor="ctr"/>
           <a:lstStyle/>
           <a:p>
-            <a:pPr indent="0" marL="0">
+            <a:pPr marL="0" indent="0">
               <a:buNone/>
             </a:pPr>
             <a:r>
@@ -2975,9 +2871,6 @@
               <a:t>• Analysis of the feasibility of the idea:
 </a:t>
             </a:r>
-            <a:pPr indent="0" marL="0">
-              <a:buNone/>
-            </a:pPr>
             <a:r>
               <a:rPr lang="en-US" sz="1100" dirty="0">
                 <a:solidFill>
@@ -2988,41 +2881,10 @@
                 <a:cs typeface="Calibri" pitchFamily="34" charset="-120"/>
               </a:rPr>
               <a:t>  - Proven Industrial Standards: Works directly with standard Modbus RTU, OPC-UA, and AVEVA PI historians.
+  - Low Latency Execution: Sub-millisecond binary search (&lt;0.1ms) enables seamless real-time analytics without cloud latency.
+  - Zero Server Overhead: Self-contained WebGL client runs in any modern browser with local laptop database fallback.
 </a:t>
             </a:r>
-            <a:pPr indent="0" marL="0">
-              <a:buNone/>
-            </a:pPr>
-            <a:r>
-              <a:rPr lang="en-US" sz="1100" dirty="0">
-                <a:solidFill>
-                  <a:srgbClr val="334155"/>
-                </a:solidFill>
-                <a:latin typeface="Calibri" pitchFamily="34" charset="0"/>
-                <a:ea typeface="Calibri" pitchFamily="34" charset="-122"/>
-                <a:cs typeface="Calibri" pitchFamily="34" charset="-120"/>
-              </a:rPr>
-              <a:t>  - Low Latency Execution: Sub-millisecond binary search (&lt;0.1ms) enables seamless real-time analytics without cloud latency.
-</a:t>
-            </a:r>
-            <a:pPr indent="0" marL="0">
-              <a:buNone/>
-            </a:pPr>
-            <a:r>
-              <a:rPr lang="en-US" sz="1100" dirty="0">
-                <a:solidFill>
-                  <a:srgbClr val="334155"/>
-                </a:solidFill>
-                <a:latin typeface="Calibri" pitchFamily="34" charset="0"/>
-                <a:ea typeface="Calibri" pitchFamily="34" charset="-122"/>
-                <a:cs typeface="Calibri" pitchFamily="34" charset="-120"/>
-              </a:rPr>
-              <a:t>  - Zero Server Overhead: Self-contained WebGL client runs in any modern browser with local laptop database fallback.
-</a:t>
-            </a:r>
-            <a:pPr indent="0" marL="0">
-              <a:buNone/>
-            </a:pPr>
             <a:r>
               <a:rPr lang="en-US" sz="1250" b="1" dirty="0">
                 <a:solidFill>
@@ -3035,9 +2897,6 @@
               <a:t>• Potential challenges and risks:
 </a:t>
             </a:r>
-            <a:pPr indent="0" marL="0">
-              <a:buNone/>
-            </a:pPr>
             <a:r>
               <a:rPr lang="en-US" sz="1100" dirty="0">
                 <a:solidFill>
@@ -3048,26 +2907,9 @@
                 <a:cs typeface="Calibri" pitchFamily="34" charset="-120"/>
               </a:rPr>
               <a:t>  - Severe deepwater sensor noise and intermittent connectivity at -2,040m seabed.
+  - High computational burden of coupled thermodynamic reservoir simulations.
 </a:t>
             </a:r>
-            <a:pPr indent="0" marL="0">
-              <a:buNone/>
-            </a:pPr>
-            <a:r>
-              <a:rPr lang="en-US" sz="1100" dirty="0">
-                <a:solidFill>
-                  <a:srgbClr val="334155"/>
-                </a:solidFill>
-                <a:latin typeface="Calibri" pitchFamily="34" charset="0"/>
-                <a:ea typeface="Calibri" pitchFamily="34" charset="-122"/>
-                <a:cs typeface="Calibri" pitchFamily="34" charset="-120"/>
-              </a:rPr>
-              <a:t>  - High computational burden of coupled thermodynamic reservoir simulations.
-</a:t>
-            </a:r>
-            <a:pPr indent="0" marL="0">
-              <a:buNone/>
-            </a:pPr>
             <a:r>
               <a:rPr lang="en-US" sz="1250" b="1" dirty="0">
                 <a:solidFill>
@@ -3080,9 +2922,6 @@
               <a:t>• Strategies for overcoming these challenges:
 </a:t>
             </a:r>
-            <a:pPr indent="0" marL="0">
-              <a:buNone/>
-            </a:pPr>
             <a:r>
               <a:rPr lang="en-US" sz="1100" dirty="0">
                 <a:solidFill>
@@ -3093,21 +2932,7 @@
                 <a:cs typeface="Calibri" pitchFamily="34" charset="-120"/>
               </a:rPr>
               <a:t>  - 1D Kalman Edge Filter: Suppresses transient bubble glitches and pressure noise locally.
-</a:t>
-            </a:r>
-            <a:pPr indent="0" marL="0">
-              <a:buNone/>
-            </a:pPr>
-            <a:r>
-              <a:rPr lang="en-US" sz="1100" dirty="0">
-                <a:solidFill>
-                  <a:srgbClr val="334155"/>
-                </a:solidFill>
-                <a:latin typeface="Calibri" pitchFamily="34" charset="0"/>
-                <a:ea typeface="Calibri" pitchFamily="34" charset="-122"/>
-                <a:cs typeface="Calibri" pitchFamily="34" charset="-120"/>
-              </a:rPr>
-              <a:t>  - Surrogate Edge AI: XGBoost classifiers act as fast surrogates while heavy physics calibrates asynchronously.</a:t>
+  - Surrogate Edge AI: XGBoost classifiers act as fast surrogates while heavy physics calibrates asynchronously.</a:t>
             </a:r>
             <a:endParaRPr lang="en-US" sz="1250" dirty="0"/>
           </a:p>
@@ -3115,14 +2940,14 @@
       </p:sp>
       <p:pic>
         <p:nvPicPr>
-          <p:cNvPr id="7" name="Image 0" descr="E:\Digital Twin\public\presentation\drill_static_casing_spinning_core_1789149401625.jpg">    </p:cNvPr>
+          <p:cNvPr id="7" name="Image 0" descr="E:\Digital Twin\public\presentation\drill_static_casing_spinning_core_1789149401625.jpg"/>
           <p:cNvPicPr>
             <a:picLocks noChangeAspect="1"/>
           </p:cNvPicPr>
           <p:nvPr/>
         </p:nvPicPr>
         <p:blipFill>
-          <a:blip r:embed="rId1"/>
+          <a:blip r:embed="rId3"/>
           <a:stretch>
             <a:fillRect/>
           </a:stretch>
@@ -3131,6 +2956,42 @@
           <a:xfrm>
             <a:off x="6583680" y="1371600"/>
             <a:ext cx="5029200" cy="4572000"/>
+          </a:xfrm>
+          <a:prstGeom prst="rect">
+            <a:avLst/>
+          </a:prstGeom>
+        </p:spPr>
+      </p:pic>
+      <p:pic>
+        <p:nvPicPr>
+          <p:cNvPr id="9" name="Picture 8">
+            <a:extLst>
+              <a:ext uri="{FF2B5EF4-FFF2-40B4-BE49-F238E27FC236}">
+                <a16:creationId xmlns:a16="http://schemas.microsoft.com/office/drawing/2014/main" id="{863E63DD-7980-B0AF-ACD3-6078EB53DA32}"/>
+              </a:ext>
+            </a:extLst>
+          </p:cNvPr>
+          <p:cNvPicPr>
+            <a:picLocks noChangeAspect="1"/>
+          </p:cNvPicPr>
+          <p:nvPr/>
+        </p:nvPicPr>
+        <p:blipFill>
+          <a:blip r:embed="rId4">
+            <a:extLst>
+              <a:ext uri="{28A0092B-C50C-407E-A947-70E740481C1C}">
+                <a14:useLocalDpi xmlns:a14="http://schemas.microsoft.com/office/drawing/2010/main" val="0"/>
+              </a:ext>
+            </a:extLst>
+          </a:blip>
+          <a:stretch>
+            <a:fillRect/>
+          </a:stretch>
+        </p:blipFill>
+        <p:spPr>
+          <a:xfrm>
+            <a:off x="9780086" y="1500"/>
+            <a:ext cx="2249850" cy="1062337"/>
           </a:xfrm>
           <a:prstGeom prst="rect">
             <a:avLst/>
@@ -3153,6 +3014,7 @@
         <a:solidFill>
           <a:srgbClr val="FFFFFF"/>
         </a:solidFill>
+        <a:effectLst/>
       </p:bgPr>
     </p:bg>
     <p:spTree>
@@ -3190,7 +3052,7 @@
           <a:bodyPr wrap="square" rtlCol="0" anchor="ctr"/>
           <a:lstStyle/>
           <a:p>
-            <a:pPr indent="0" marL="0">
+            <a:pPr marL="0" indent="0">
               <a:buNone/>
             </a:pPr>
             <a:r>
@@ -3229,7 +3091,7 @@
           <a:bodyPr wrap="square" rtlCol="0" anchor="ctr"/>
           <a:lstStyle/>
           <a:p>
-            <a:pPr indent="0" marL="0">
+            <a:pPr marL="0" indent="0">
               <a:buNone/>
             </a:pPr>
             <a:r>
@@ -3268,7 +3130,7 @@
           <a:bodyPr wrap="square" rtlCol="0" anchor="ctr"/>
           <a:lstStyle/>
           <a:p>
-            <a:pPr indent="0" marL="0">
+            <a:pPr marL="0" indent="0">
               <a:buNone/>
             </a:pPr>
             <a:r>
@@ -3307,7 +3169,7 @@
           <a:bodyPr wrap="square" rtlCol="0" anchor="ctr"/>
           <a:lstStyle/>
           <a:p>
-            <a:pPr algn="r" indent="0" marL="0">
+            <a:pPr marL="0" indent="0" algn="r">
               <a:buNone/>
             </a:pPr>
             <a:r>
@@ -3373,7 +3235,7 @@
           <a:bodyPr wrap="square" rtlCol="0" anchor="ctr"/>
           <a:lstStyle/>
           <a:p>
-            <a:pPr indent="0" marL="0">
+            <a:pPr marL="0" indent="0">
               <a:buNone/>
             </a:pPr>
             <a:r>
@@ -3412,7 +3274,7 @@
           <a:bodyPr wrap="square" rtlCol="0" anchor="ctr"/>
           <a:lstStyle/>
           <a:p>
-            <a:pPr indent="0" marL="0">
+            <a:pPr marL="0" indent="0">
               <a:buNone/>
             </a:pPr>
             <a:r>
@@ -3427,9 +3289,6 @@
               <a:t>• Deepwater Subsea Optimization:
 </a:t>
             </a:r>
-            <a:pPr indent="0" marL="0">
-              <a:buNone/>
-            </a:pPr>
             <a:r>
               <a:rPr lang="en-US" sz="1050" dirty="0">
                 <a:solidFill>
@@ -3442,9 +3301,6 @@
               <a:t>  Unlocks actionable visibility into deepwater manifolds, enabling higher extraction rates from ultra-deep offshore blocks.
 </a:t>
             </a:r>
-            <a:pPr indent="0" marL="0">
-              <a:buNone/>
-            </a:pPr>
             <a:r>
               <a:rPr lang="en-US" sz="1100" b="1" dirty="0">
                 <a:solidFill>
@@ -3457,9 +3313,6 @@
               <a:t>• Predictive Health &amp; Asset Life:
 </a:t>
             </a:r>
-            <a:pPr indent="0" marL="0">
-              <a:buNone/>
-            </a:pPr>
             <a:r>
               <a:rPr lang="en-US" sz="1050" dirty="0">
                 <a:solidFill>
@@ -3472,9 +3325,6 @@
               <a:t>  Maximizes lifespan of drill strings, subsea risers, and topside separators by preventing fatigue and over-torque.
 </a:t>
             </a:r>
-            <a:pPr indent="0" marL="0">
-              <a:buNone/>
-            </a:pPr>
             <a:r>
               <a:rPr lang="en-US" sz="1100" b="1" dirty="0">
                 <a:solidFill>
@@ -3487,9 +3337,6 @@
               <a:t>• Shift to Autonomous Supervision:
 </a:t>
             </a:r>
-            <a:pPr indent="0" marL="0">
-              <a:buNone/>
-            </a:pPr>
             <a:r>
               <a:rPr lang="en-US" sz="1050" dirty="0">
                 <a:solidFill>
@@ -3502,9 +3349,6 @@
               <a:t>  Transforms control room operations from reactive fire-fighting to autonomous AI-driven supervisory guidance.
 </a:t>
             </a:r>
-            <a:pPr indent="0" marL="0">
-              <a:buNone/>
-            </a:pPr>
             <a:r>
               <a:rPr lang="en-US" sz="1100" b="1" dirty="0">
                 <a:solidFill>
@@ -3517,9 +3361,6 @@
               <a:t>• Environmental Safety (Zero Spills):
 </a:t>
             </a:r>
-            <a:pPr indent="0" marL="0">
-              <a:buNone/>
-            </a:pPr>
             <a:r>
               <a:rPr lang="en-US" sz="1050" dirty="0">
                 <a:solidFill>
@@ -3583,7 +3424,7 @@
           <a:bodyPr wrap="square" rtlCol="0" anchor="ctr"/>
           <a:lstStyle/>
           <a:p>
-            <a:pPr indent="0" marL="0">
+            <a:pPr marL="0" indent="0">
               <a:buNone/>
             </a:pPr>
             <a:r>
@@ -3622,7 +3463,7 @@
           <a:bodyPr wrap="square" rtlCol="0" anchor="ctr"/>
           <a:lstStyle/>
           <a:p>
-            <a:pPr indent="0" marL="0">
+            <a:pPr marL="0" indent="0">
               <a:buNone/>
             </a:pPr>
             <a:r>
@@ -3636,9 +3477,6 @@
               </a:rPr>
               <a:t>• Cost Recovery: </a:t>
             </a:r>
-            <a:pPr indent="0" marL="0">
-              <a:buNone/>
-            </a:pPr>
             <a:r>
               <a:rPr lang="en-US" sz="1050" dirty="0">
                 <a:solidFill>
@@ -3651,9 +3489,6 @@
               <a:t>₹25+ Lakhs saved per incident through proactive anomaly detection and automated pump speed throttling.
 </a:t>
             </a:r>
-            <a:pPr indent="0" marL="0">
-              <a:buNone/>
-            </a:pPr>
             <a:r>
               <a:rPr lang="en-US" sz="1100" b="1" dirty="0">
                 <a:solidFill>
@@ -3665,9 +3500,6 @@
               </a:rPr>
               <a:t>• 35% Downtime Reduction: </a:t>
             </a:r>
-            <a:pPr indent="0" marL="0">
-              <a:buNone/>
-            </a:pPr>
             <a:r>
               <a:rPr lang="en-US" sz="1050" dirty="0">
                 <a:solidFill>
@@ -3680,9 +3512,6 @@
               <a:t>Automated 12:00 Midnight reconciliation and instant incident dispatch reduce mean time to resolution.
 </a:t>
             </a:r>
-            <a:pPr indent="0" marL="0">
-              <a:buNone/>
-            </a:pPr>
             <a:r>
               <a:rPr lang="en-US" sz="1100" b="1" dirty="0">
                 <a:solidFill>
@@ -3694,9 +3523,6 @@
               </a:rPr>
               <a:t>• 40% Lifting Cost Reduction: </a:t>
             </a:r>
-            <a:pPr indent="0" marL="0">
-              <a:buNone/>
-            </a:pPr>
             <a:r>
               <a:rPr lang="en-US" sz="1050" dirty="0">
                 <a:solidFill>
@@ -3709,9 +3535,6 @@
               <a:t>Optimized multiphase fluid balance and ASTM D1250 purification minimize energy and demulsifier waste.
 </a:t>
             </a:r>
-            <a:pPr indent="0" marL="0">
-              <a:buNone/>
-            </a:pPr>
             <a:r>
               <a:rPr lang="en-US" sz="1100" b="1" dirty="0">
                 <a:solidFill>
@@ -3723,9 +3546,6 @@
               </a:rPr>
               <a:t>• 100% Regulatory Compliance: </a:t>
             </a:r>
-            <a:pPr indent="0" marL="0">
-              <a:buNone/>
-            </a:pPr>
             <a:r>
               <a:rPr lang="en-US" sz="1050" dirty="0">
                 <a:solidFill>
@@ -3741,6 +3561,42 @@
           </a:p>
         </p:txBody>
       </p:sp>
+      <p:pic>
+        <p:nvPicPr>
+          <p:cNvPr id="13" name="Picture 12">
+            <a:extLst>
+              <a:ext uri="{FF2B5EF4-FFF2-40B4-BE49-F238E27FC236}">
+                <a16:creationId xmlns:a16="http://schemas.microsoft.com/office/drawing/2014/main" id="{428281C3-9C24-CE32-6885-BC6E27A9A06C}"/>
+              </a:ext>
+            </a:extLst>
+          </p:cNvPr>
+          <p:cNvPicPr>
+            <a:picLocks noChangeAspect="1"/>
+          </p:cNvPicPr>
+          <p:nvPr/>
+        </p:nvPicPr>
+        <p:blipFill>
+          <a:blip r:embed="rId3">
+            <a:extLst>
+              <a:ext uri="{28A0092B-C50C-407E-A947-70E740481C1C}">
+                <a14:useLocalDpi xmlns:a14="http://schemas.microsoft.com/office/drawing/2010/main" val="0"/>
+              </a:ext>
+            </a:extLst>
+          </a:blip>
+          <a:stretch>
+            <a:fillRect/>
+          </a:stretch>
+        </p:blipFill>
+        <p:spPr>
+          <a:xfrm>
+            <a:off x="9780086" y="1500"/>
+            <a:ext cx="2249850" cy="1062337"/>
+          </a:xfrm>
+          <a:prstGeom prst="rect">
+            <a:avLst/>
+          </a:prstGeom>
+        </p:spPr>
+      </p:pic>
     </p:spTree>
   </p:cSld>
   <p:clrMapOvr>
@@ -3757,6 +3613,7 @@
         <a:solidFill>
           <a:srgbClr val="FFFFFF"/>
         </a:solidFill>
+        <a:effectLst/>
       </p:bgPr>
     </p:bg>
     <p:spTree>
@@ -3794,7 +3651,7 @@
           <a:bodyPr wrap="square" rtlCol="0" anchor="ctr"/>
           <a:lstStyle/>
           <a:p>
-            <a:pPr indent="0" marL="0">
+            <a:pPr marL="0" indent="0">
               <a:buNone/>
             </a:pPr>
             <a:r>
@@ -3833,7 +3690,7 @@
           <a:bodyPr wrap="square" rtlCol="0" anchor="ctr"/>
           <a:lstStyle/>
           <a:p>
-            <a:pPr indent="0" marL="0">
+            <a:pPr marL="0" indent="0">
               <a:buNone/>
             </a:pPr>
             <a:r>
@@ -3872,7 +3729,7 @@
           <a:bodyPr wrap="square" rtlCol="0" anchor="ctr"/>
           <a:lstStyle/>
           <a:p>
-            <a:pPr indent="0" marL="0">
+            <a:pPr marL="0" indent="0">
               <a:buNone/>
             </a:pPr>
             <a:r>
@@ -3911,7 +3768,7 @@
           <a:bodyPr wrap="square" rtlCol="0" anchor="ctr"/>
           <a:lstStyle/>
           <a:p>
-            <a:pPr algn="r" indent="0" marL="0">
+            <a:pPr marL="0" indent="0" algn="r">
               <a:buNone/>
             </a:pPr>
             <a:r>
@@ -3950,7 +3807,7 @@
           <a:bodyPr wrap="square" rtlCol="0" anchor="ctr"/>
           <a:lstStyle/>
           <a:p>
-            <a:pPr indent="0" marL="0">
+            <a:pPr marL="0" indent="0">
               <a:buNone/>
             </a:pPr>
             <a:r>
@@ -3989,7 +3846,7 @@
           <a:bodyPr wrap="square" rtlCol="0" anchor="ctr"/>
           <a:lstStyle/>
           <a:p>
-            <a:pPr indent="0" marL="0">
+            <a:pPr marL="0" indent="0">
               <a:buNone/>
             </a:pPr>
             <a:r>
@@ -4004,9 +3861,6 @@
               <a:t>• ASTM D1250 &amp; API MPMS Chapter 11.1 Standards:
 </a:t>
             </a:r>
-            <a:pPr indent="0" marL="0">
-              <a:buNone/>
-            </a:pPr>
             <a:r>
               <a:rPr lang="en-US" sz="1100" dirty="0">
                 <a:solidFill>
@@ -4019,9 +3873,6 @@
               <a:t>  Standardized equations for temperature &amp; pressure volume correction factors (CTL/CPL) for crude oils.
 </a:t>
             </a:r>
-            <a:pPr indent="0" marL="0">
-              <a:buNone/>
-            </a:pPr>
             <a:r>
               <a:rPr lang="en-US" sz="1150" b="1" dirty="0">
                 <a:solidFill>
@@ -4034,9 +3885,6 @@
               <a:t>• Coriolis Resonance &amp; Darcy-Weisbach Multiphase Mechanics:
 </a:t>
             </a:r>
-            <a:pPr indent="0" marL="0">
-              <a:buNone/>
-            </a:pPr>
             <a:r>
               <a:rPr lang="en-US" sz="1100" dirty="0">
                 <a:solidFill>
@@ -4049,9 +3897,6 @@
               <a:t>  Mathematical formulation for tube frequency inversion and subsea pipeline friction factor calculations.
 </a:t>
             </a:r>
-            <a:pPr indent="0" marL="0">
-              <a:buNone/>
-            </a:pPr>
             <a:r>
               <a:rPr lang="en-US" sz="1150" b="1" dirty="0">
                 <a:solidFill>
@@ -4064,9 +3909,6 @@
               <a:t>• 1D Kalman Filtering for Industrial SCADA Denoising:
 </a:t>
             </a:r>
-            <a:pPr indent="0" marL="0">
-              <a:buNone/>
-            </a:pPr>
             <a:r>
               <a:rPr lang="en-US" sz="1100" dirty="0">
                 <a:solidFill>
@@ -4079,9 +3921,6 @@
               <a:t>  Discrete recursive Bayesian state estimation for high-frequency telemetry streams.
 </a:t>
             </a:r>
-            <a:pPr indent="0" marL="0">
-              <a:buNone/>
-            </a:pPr>
             <a:r>
               <a:rPr lang="en-US" sz="1150" b="1" dirty="0">
                 <a:solidFill>
@@ -4094,9 +3933,6 @@
               <a:t>• WebGL &amp; Three.js for 3D Cyber-Physical Spatial Computing:
 </a:t>
             </a:r>
-            <a:pPr indent="0" marL="0">
-              <a:buNone/>
-            </a:pPr>
             <a:r>
               <a:rPr lang="en-US" sz="1100" dirty="0">
                 <a:solidFill>
@@ -4109,9 +3945,6 @@
               <a:t>  High-performance GPU-accelerated rendering of complex offshore assemblies with real-time gesture interaction.
 </a:t>
             </a:r>
-            <a:pPr indent="0" marL="0">
-              <a:buNone/>
-            </a:pPr>
             <a:r>
               <a:rPr lang="en-US" sz="1150" b="1" dirty="0">
                 <a:solidFill>
@@ -4124,9 +3957,6 @@
               <a:t>• DGH (Directorate General of Hydrocarbons) Offshore Reporting Guidelines:
 </a:t>
             </a:r>
-            <a:pPr indent="0" marL="0">
-              <a:buNone/>
-            </a:pPr>
             <a:r>
               <a:rPr lang="en-US" sz="1100" dirty="0">
                 <a:solidFill>
@@ -4144,14 +3974,14 @@
       </p:sp>
       <p:pic>
         <p:nvPicPr>
-          <p:cNvPr id="8" name="Image 0" descr="E:\Digital Twin\public\presentation\subsea_pipes_glowing_arrows_1789149758412.jpg">    </p:cNvPr>
+          <p:cNvPr id="8" name="Image 0" descr="E:\Digital Twin\public\presentation\subsea_pipes_glowing_arrows_1789149758412.jpg"/>
           <p:cNvPicPr>
             <a:picLocks noChangeAspect="1"/>
           </p:cNvPicPr>
           <p:nvPr/>
         </p:nvPicPr>
         <p:blipFill>
-          <a:blip r:embed="rId1"/>
+          <a:blip r:embed="rId3"/>
           <a:stretch>
             <a:fillRect/>
           </a:stretch>
@@ -4160,6 +3990,42 @@
           <a:xfrm>
             <a:off x="6949440" y="1691640"/>
             <a:ext cx="4663440" cy="4297680"/>
+          </a:xfrm>
+          <a:prstGeom prst="rect">
+            <a:avLst/>
+          </a:prstGeom>
+        </p:spPr>
+      </p:pic>
+      <p:pic>
+        <p:nvPicPr>
+          <p:cNvPr id="10" name="Picture 9">
+            <a:extLst>
+              <a:ext uri="{FF2B5EF4-FFF2-40B4-BE49-F238E27FC236}">
+                <a16:creationId xmlns:a16="http://schemas.microsoft.com/office/drawing/2014/main" id="{70AC4C77-8BCF-BF3B-33B9-1B91301B396E}"/>
+              </a:ext>
+            </a:extLst>
+          </p:cNvPr>
+          <p:cNvPicPr>
+            <a:picLocks noChangeAspect="1"/>
+          </p:cNvPicPr>
+          <p:nvPr/>
+        </p:nvPicPr>
+        <p:blipFill>
+          <a:blip r:embed="rId4">
+            <a:extLst>
+              <a:ext uri="{28A0092B-C50C-407E-A947-70E740481C1C}">
+                <a14:useLocalDpi xmlns:a14="http://schemas.microsoft.com/office/drawing/2010/main" val="0"/>
+              </a:ext>
+            </a:extLst>
+          </a:blip>
+          <a:stretch>
+            <a:fillRect/>
+          </a:stretch>
+        </p:blipFill>
+        <p:spPr>
+          <a:xfrm>
+            <a:off x="9780086" y="1500"/>
+            <a:ext cx="2249850" cy="1062337"/>
           </a:xfrm>
           <a:prstGeom prst="rect">
             <a:avLst/>
@@ -4467,4 +4333,319 @@
     </a:ext>
   </a:extLst>
 </a:theme>
+</file>
+
+<file path=ppt/theme/theme2.xml><?xml version="1.0" encoding="utf-8"?>
+<a:theme xmlns:a="http://schemas.openxmlformats.org/drawingml/2006/main" name="Office Theme">
+  <a:themeElements>
+    <a:clrScheme name="Office">
+      <a:dk1>
+        <a:sysClr val="windowText" lastClr="000000"/>
+      </a:dk1>
+      <a:lt1>
+        <a:sysClr val="window" lastClr="FFFFFF"/>
+      </a:lt1>
+      <a:dk2>
+        <a:srgbClr val="0E2841"/>
+      </a:dk2>
+      <a:lt2>
+        <a:srgbClr val="E8E8E8"/>
+      </a:lt2>
+      <a:accent1>
+        <a:srgbClr val="156082"/>
+      </a:accent1>
+      <a:accent2>
+        <a:srgbClr val="E97132"/>
+      </a:accent2>
+      <a:accent3>
+        <a:srgbClr val="196B24"/>
+      </a:accent3>
+      <a:accent4>
+        <a:srgbClr val="0F9ED5"/>
+      </a:accent4>
+      <a:accent5>
+        <a:srgbClr val="A02B93"/>
+      </a:accent5>
+      <a:accent6>
+        <a:srgbClr val="4EA72E"/>
+      </a:accent6>
+      <a:hlink>
+        <a:srgbClr val="467886"/>
+      </a:hlink>
+      <a:folHlink>
+        <a:srgbClr val="96607D"/>
+      </a:folHlink>
+    </a:clrScheme>
+    <a:fontScheme name="Office">
+      <a:majorFont>
+        <a:latin typeface="Aptos Display" panose="02110004020202020204"/>
+        <a:ea typeface=""/>
+        <a:cs typeface=""/>
+        <a:font script="Jpan" typeface="游ゴシック Light"/>
+        <a:font script="Hang" typeface="맑은 고딕"/>
+        <a:font script="Hans" typeface="等线 Light"/>
+        <a:font script="Hant" typeface="新細明體"/>
+        <a:font script="Arab" typeface="Times New Roman"/>
+        <a:font script="Hebr" typeface="Times New Roman"/>
+        <a:font script="Thai" typeface="Angsana New"/>
+        <a:font script="Ethi" typeface="Nyala"/>
+        <a:font script="Beng" typeface="Vrinda"/>
+        <a:font script="Gujr" typeface="Shruti"/>
+        <a:font script="Khmr" typeface="MoolBoran"/>
+        <a:font script="Knda" typeface="Tunga"/>
+        <a:font script="Guru" typeface="Raavi"/>
+        <a:font script="Cans" typeface="Euphemia"/>
+        <a:font script="Cher" typeface="Plantagenet Cherokee"/>
+        <a:font script="Yiii" typeface="Microsoft Yi Baiti"/>
+        <a:font script="Tibt" typeface="Microsoft Himalaya"/>
+        <a:font script="Thaa" typeface="MV Boli"/>
+        <a:font script="Deva" typeface="Mangal"/>
+        <a:font script="Telu" typeface="Gautami"/>
+        <a:font script="Taml" typeface="Latha"/>
+        <a:font script="Syrc" typeface="Estrangelo Edessa"/>
+        <a:font script="Orya" typeface="Kalinga"/>
+        <a:font script="Mlym" typeface="Kartika"/>
+        <a:font script="Laoo" typeface="DokChampa"/>
+        <a:font script="Sinh" typeface="Iskoola Pota"/>
+        <a:font script="Mong" typeface="Mongolian Baiti"/>
+        <a:font script="Viet" typeface="Times New Roman"/>
+        <a:font script="Uigh" typeface="Microsoft Uighur"/>
+        <a:font script="Geor" typeface="Sylfaen"/>
+        <a:font script="Armn" typeface="Arial"/>
+        <a:font script="Bugi" typeface="Leelawadee UI"/>
+        <a:font script="Bopo" typeface="Microsoft JhengHei"/>
+        <a:font script="Java" typeface="Javanese Text"/>
+        <a:font script="Lisu" typeface="Segoe UI"/>
+        <a:font script="Mymr" typeface="Myanmar Text"/>
+        <a:font script="Nkoo" typeface="Ebrima"/>
+        <a:font script="Olck" typeface="Nirmala UI"/>
+        <a:font script="Osma" typeface="Ebrima"/>
+        <a:font script="Phag" typeface="Phagspa"/>
+        <a:font script="Syrn" typeface="Estrangelo Edessa"/>
+        <a:font script="Syrj" typeface="Estrangelo Edessa"/>
+        <a:font script="Syre" typeface="Estrangelo Edessa"/>
+        <a:font script="Sora" typeface="Nirmala UI"/>
+        <a:font script="Tale" typeface="Microsoft Tai Le"/>
+        <a:font script="Talu" typeface="Microsoft New Tai Lue"/>
+        <a:font script="Tfng" typeface="Ebrima"/>
+      </a:majorFont>
+      <a:minorFont>
+        <a:latin typeface="Aptos" panose="02110004020202020204"/>
+        <a:ea typeface=""/>
+        <a:cs typeface=""/>
+        <a:font script="Jpan" typeface="游ゴシック"/>
+        <a:font script="Hang" typeface="맑은 고딕"/>
+        <a:font script="Hans" typeface="等线"/>
+        <a:font script="Hant" typeface="新細明體"/>
+        <a:font script="Arab" typeface="Arial"/>
+        <a:font script="Hebr" typeface="Arial"/>
+        <a:font script="Thai" typeface="Cordia New"/>
+        <a:font script="Ethi" typeface="Nyala"/>
+        <a:font script="Beng" typeface="Vrinda"/>
+        <a:font script="Gujr" typeface="Shruti"/>
+        <a:font script="Khmr" typeface="DaunPenh"/>
+        <a:font script="Knda" typeface="Tunga"/>
+        <a:font script="Guru" typeface="Raavi"/>
+        <a:font script="Cans" typeface="Euphemia"/>
+        <a:font script="Cher" typeface="Plantagenet Cherokee"/>
+        <a:font script="Yiii" typeface="Microsoft Yi Baiti"/>
+        <a:font script="Tibt" typeface="Microsoft Himalaya"/>
+        <a:font script="Thaa" typeface="MV Boli"/>
+        <a:font script="Deva" typeface="Mangal"/>
+        <a:font script="Telu" typeface="Gautami"/>
+        <a:font script="Taml" typeface="Latha"/>
+        <a:font script="Syrc" typeface="Estrangelo Edessa"/>
+        <a:font script="Orya" typeface="Kalinga"/>
+        <a:font script="Mlym" typeface="Kartika"/>
+        <a:font script="Laoo" typeface="DokChampa"/>
+        <a:font script="Sinh" typeface="Iskoola Pota"/>
+        <a:font script="Mong" typeface="Mongolian Baiti"/>
+        <a:font script="Viet" typeface="Arial"/>
+        <a:font script="Uigh" typeface="Microsoft Uighur"/>
+        <a:font script="Geor" typeface="Sylfaen"/>
+        <a:font script="Armn" typeface="Arial"/>
+        <a:font script="Bugi" typeface="Leelawadee UI"/>
+        <a:font script="Bopo" typeface="Microsoft JhengHei"/>
+        <a:font script="Java" typeface="Javanese Text"/>
+        <a:font script="Lisu" typeface="Segoe UI"/>
+        <a:font script="Mymr" typeface="Myanmar Text"/>
+        <a:font script="Nkoo" typeface="Ebrima"/>
+        <a:font script="Olck" typeface="Nirmala UI"/>
+        <a:font script="Osma" typeface="Ebrima"/>
+        <a:font script="Phag" typeface="Phagspa"/>
+        <a:font script="Syrn" typeface="Estrangelo Edessa"/>
+        <a:font script="Syrj" typeface="Estrangelo Edessa"/>
+        <a:font script="Syre" typeface="Estrangelo Edessa"/>
+        <a:font script="Sora" typeface="Nirmala UI"/>
+        <a:font script="Tale" typeface="Microsoft Tai Le"/>
+        <a:font script="Talu" typeface="Microsoft New Tai Lue"/>
+        <a:font script="Tfng" typeface="Ebrima"/>
+      </a:minorFont>
+    </a:fontScheme>
+    <a:fmtScheme name="Office">
+      <a:fillStyleLst>
+        <a:solidFill>
+          <a:schemeClr val="phClr"/>
+        </a:solidFill>
+        <a:gradFill rotWithShape="1">
+          <a:gsLst>
+            <a:gs pos="0">
+              <a:schemeClr val="phClr">
+                <a:lumMod val="110000"/>
+                <a:satMod val="105000"/>
+                <a:tint val="67000"/>
+              </a:schemeClr>
+            </a:gs>
+            <a:gs pos="50000">
+              <a:schemeClr val="phClr">
+                <a:lumMod val="105000"/>
+                <a:satMod val="103000"/>
+                <a:tint val="73000"/>
+              </a:schemeClr>
+            </a:gs>
+            <a:gs pos="100000">
+              <a:schemeClr val="phClr">
+                <a:lumMod val="105000"/>
+                <a:satMod val="109000"/>
+                <a:tint val="81000"/>
+              </a:schemeClr>
+            </a:gs>
+          </a:gsLst>
+          <a:lin ang="5400000" scaled="0"/>
+        </a:gradFill>
+        <a:gradFill rotWithShape="1">
+          <a:gsLst>
+            <a:gs pos="0">
+              <a:schemeClr val="phClr">
+                <a:satMod val="103000"/>
+                <a:lumMod val="102000"/>
+                <a:tint val="94000"/>
+              </a:schemeClr>
+            </a:gs>
+            <a:gs pos="50000">
+              <a:schemeClr val="phClr">
+                <a:satMod val="110000"/>
+                <a:lumMod val="100000"/>
+                <a:shade val="100000"/>
+              </a:schemeClr>
+            </a:gs>
+            <a:gs pos="100000">
+              <a:schemeClr val="phClr">
+                <a:lumMod val="99000"/>
+                <a:satMod val="120000"/>
+                <a:shade val="78000"/>
+              </a:schemeClr>
+            </a:gs>
+          </a:gsLst>
+          <a:lin ang="5400000" scaled="0"/>
+        </a:gradFill>
+      </a:fillStyleLst>
+      <a:lnStyleLst>
+        <a:ln w="12700" cap="flat" cmpd="sng" algn="ctr">
+          <a:solidFill>
+            <a:schemeClr val="phClr"/>
+          </a:solidFill>
+          <a:prstDash val="solid"/>
+          <a:miter lim="800000"/>
+        </a:ln>
+        <a:ln w="19050" cap="flat" cmpd="sng" algn="ctr">
+          <a:solidFill>
+            <a:schemeClr val="phClr"/>
+          </a:solidFill>
+          <a:prstDash val="solid"/>
+          <a:miter lim="800000"/>
+        </a:ln>
+        <a:ln w="25400" cap="flat" cmpd="sng" algn="ctr">
+          <a:solidFill>
+            <a:schemeClr val="phClr"/>
+          </a:solidFill>
+          <a:prstDash val="solid"/>
+          <a:miter lim="800000"/>
+        </a:ln>
+      </a:lnStyleLst>
+      <a:effectStyleLst>
+        <a:effectStyle>
+          <a:effectLst/>
+        </a:effectStyle>
+        <a:effectStyle>
+          <a:effectLst/>
+        </a:effectStyle>
+        <a:effectStyle>
+          <a:effectLst>
+            <a:outerShdw blurRad="57150" dist="19050" dir="5400000" algn="ctr" rotWithShape="0">
+              <a:srgbClr val="000000">
+                <a:alpha val="63000"/>
+              </a:srgbClr>
+            </a:outerShdw>
+          </a:effectLst>
+        </a:effectStyle>
+      </a:effectStyleLst>
+      <a:bgFillStyleLst>
+        <a:solidFill>
+          <a:schemeClr val="phClr"/>
+        </a:solidFill>
+        <a:solidFill>
+          <a:schemeClr val="phClr">
+            <a:tint val="95000"/>
+            <a:satMod val="170000"/>
+          </a:schemeClr>
+        </a:solidFill>
+        <a:gradFill rotWithShape="1">
+          <a:gsLst>
+            <a:gs pos="0">
+              <a:schemeClr val="phClr">
+                <a:tint val="93000"/>
+                <a:satMod val="150000"/>
+                <a:shade val="98000"/>
+                <a:lumMod val="102000"/>
+              </a:schemeClr>
+            </a:gs>
+            <a:gs pos="50000">
+              <a:schemeClr val="phClr">
+                <a:tint val="98000"/>
+                <a:satMod val="130000"/>
+                <a:shade val="90000"/>
+                <a:lumMod val="103000"/>
+              </a:schemeClr>
+            </a:gs>
+            <a:gs pos="100000">
+              <a:schemeClr val="phClr">
+                <a:shade val="63000"/>
+                <a:satMod val="120000"/>
+              </a:schemeClr>
+            </a:gs>
+          </a:gsLst>
+          <a:lin ang="5400000" scaled="0"/>
+        </a:gradFill>
+      </a:bgFillStyleLst>
+    </a:fmtScheme>
+  </a:themeElements>
+  <a:objectDefaults>
+    <a:lnDef>
+      <a:spPr/>
+      <a:bodyPr/>
+      <a:lstStyle/>
+      <a:style>
+        <a:lnRef idx="2">
+          <a:schemeClr val="accent1"/>
+        </a:lnRef>
+        <a:fillRef idx="0">
+          <a:schemeClr val="accent1"/>
+        </a:fillRef>
+        <a:effectRef idx="1">
+          <a:schemeClr val="accent1"/>
+        </a:effectRef>
+        <a:fontRef idx="minor">
+          <a:schemeClr val="tx1"/>
+        </a:fontRef>
+      </a:style>
+    </a:lnDef>
+  </a:objectDefaults>
+  <a:extraClrSchemeLst/>
+  <a:extLst>
+    <a:ext uri="{05A4C25C-085E-4340-85A3-A5531E510DB2}">
+      <thm15:themeFamily xmlns:thm15="http://schemas.microsoft.com/office/thememl/2012/main" name="Office Theme" id="{2E142A2C-CD16-42D6-873A-C26D2A0506FA}" vid="{1BDDFF52-6CD6-40A5-AB3C-68EB2F1E4D0A}"/>
+    </a:ext>
+  </a:extLst>
+</a:theme>
 </file>
</xml_diff>